<commit_message>
feat: split multiple circled graphs into individual files
</commit_message>
<xml_diff>
--- a/output/2.pptx
+++ b/output/2.pptx
@@ -3174,8 +3174,8 @@
         </p:nvCxnSpPr>
         <p:spPr>
           <a:xfrm flipV="1">
-            <a:off x="4572000.0" y="2571018.48"/>
-            <a:ext cx="22860.0" cy="731.5200000000186"/>
+            <a:off x="4800600.0" y="2457450.0"/>
+            <a:ext cx="45720.0" cy="22860.0"/>
           </a:xfrm>
           <a:prstGeom prst="line">
             <a:avLst/>
@@ -3209,8 +3209,8 @@
         </p:nvCxnSpPr>
         <p:spPr>
           <a:xfrm flipV="1">
-            <a:off x="4594860.0" y="2568778.2"/>
-            <a:ext cx="22860.0" cy="2240.279999999795"/>
+            <a:off x="4846320.0" y="2430018.0"/>
+            <a:ext cx="45720.0" cy="27432.0"/>
           </a:xfrm>
           <a:prstGeom prst="line">
             <a:avLst/>
@@ -3244,8 +3244,8 @@
         </p:nvCxnSpPr>
         <p:spPr>
           <a:xfrm flipV="1">
-            <a:off x="4617720.0" y="2565074.88"/>
-            <a:ext cx="22860.0" cy="3703.320000000298"/>
+            <a:off x="4892040.0" y="2393442.0"/>
+            <a:ext cx="45720.0" cy="36576.0"/>
           </a:xfrm>
           <a:prstGeom prst="line">
             <a:avLst/>
@@ -3279,8 +3279,8 @@
         </p:nvCxnSpPr>
         <p:spPr>
           <a:xfrm flipV="1">
-            <a:off x="4640580.0" y="2559862.8"/>
-            <a:ext cx="22860.0" cy="5212.0800000000745"/>
+            <a:off x="4937760.0" y="2356866.0"/>
+            <a:ext cx="45720.0" cy="36576.0"/>
           </a:xfrm>
           <a:prstGeom prst="line">
             <a:avLst/>
@@ -3314,8 +3314,8 @@
         </p:nvCxnSpPr>
         <p:spPr>
           <a:xfrm flipV="1">
-            <a:off x="4663440.0" y="2553187.68"/>
-            <a:ext cx="22860.0" cy="6675.119999999646"/>
+            <a:off x="4983480.0" y="2315718.0"/>
+            <a:ext cx="45720.0" cy="41148.0"/>
           </a:xfrm>
           <a:prstGeom prst="line">
             <a:avLst/>
@@ -3349,8 +3349,8 @@
         </p:nvCxnSpPr>
         <p:spPr>
           <a:xfrm flipV="1">
-            <a:off x="4686300.0" y="2545003.8"/>
-            <a:ext cx="22860.0" cy="8183.880000000354"/>
+            <a:off x="5029200.0" y="2269998.0"/>
+            <a:ext cx="45720.0" cy="45720.0"/>
           </a:xfrm>
           <a:prstGeom prst="line">
             <a:avLst/>
@@ -3384,8 +3384,8 @@
         </p:nvCxnSpPr>
         <p:spPr>
           <a:xfrm flipV="1">
-            <a:off x="4709160.0" y="2535356.88"/>
-            <a:ext cx="22860.0" cy="9646.919999999925"/>
+            <a:off x="5074920.0" y="2219706.0"/>
+            <a:ext cx="45720.0" cy="50292.0"/>
           </a:xfrm>
           <a:prstGeom prst="line">
             <a:avLst/>
@@ -3419,8 +3419,8 @@
         </p:nvCxnSpPr>
         <p:spPr>
           <a:xfrm flipV="1">
-            <a:off x="4732020.0" y="2524201.2"/>
-            <a:ext cx="22860.0" cy="11155.679999999702"/>
+            <a:off x="5120640.0" y="2164842.0"/>
+            <a:ext cx="45720.0" cy="54864.0"/>
           </a:xfrm>
           <a:prstGeom prst="line">
             <a:avLst/>
@@ -3454,8 +3454,8 @@
         </p:nvCxnSpPr>
         <p:spPr>
           <a:xfrm flipV="1">
-            <a:off x="4754880.0" y="2511582.48"/>
-            <a:ext cx="22860.0" cy="12618.720000000205"/>
+            <a:off x="5166360.0" y="2105406.0"/>
+            <a:ext cx="45720.0" cy="59436.0"/>
           </a:xfrm>
           <a:prstGeom prst="line">
             <a:avLst/>
@@ -3489,8 +3489,8 @@
         </p:nvCxnSpPr>
         <p:spPr>
           <a:xfrm flipV="1">
-            <a:off x="4777740.0" y="2497455.0"/>
-            <a:ext cx="22860.0" cy="14127.479999999981"/>
+            <a:off x="5212080.0" y="2041398.0"/>
+            <a:ext cx="45720.0" cy="64008.0"/>
           </a:xfrm>
           <a:prstGeom prst="line">
             <a:avLst/>
@@ -3524,8 +3524,8 @@
         </p:nvCxnSpPr>
         <p:spPr>
           <a:xfrm flipV="1">
-            <a:off x="4800600.0" y="2481864.48"/>
-            <a:ext cx="22860.0" cy="15590.520000000019"/>
+            <a:off x="5257800.0" y="1972818.0"/>
+            <a:ext cx="45720.0" cy="68580.0"/>
           </a:xfrm>
           <a:prstGeom prst="line">
             <a:avLst/>
@@ -3559,8 +3559,8 @@
         </p:nvCxnSpPr>
         <p:spPr>
           <a:xfrm flipV="1">
-            <a:off x="4823460.0" y="2464765.2"/>
-            <a:ext cx="22860.0" cy="17099.279999999795"/>
+            <a:off x="5303520.0" y="1899666.0"/>
+            <a:ext cx="45720.0" cy="73152.0"/>
           </a:xfrm>
           <a:prstGeom prst="line">
             <a:avLst/>
@@ -3594,8 +3594,8 @@
         </p:nvCxnSpPr>
         <p:spPr>
           <a:xfrm flipV="1">
-            <a:off x="4846320.0" y="2446202.88"/>
-            <a:ext cx="22860.0" cy="18562.320000000298"/>
+            <a:off x="5349240.0" y="1821942.0"/>
+            <a:ext cx="45720.0" cy="77724.0"/>
           </a:xfrm>
           <a:prstGeom prst="line">
             <a:avLst/>
@@ -3629,8 +3629,8 @@
         </p:nvCxnSpPr>
         <p:spPr>
           <a:xfrm flipV="1">
-            <a:off x="4869180.0" y="2426131.8"/>
-            <a:ext cx="22860.0" cy="20071.080000000075"/>
+            <a:off x="5394960.0" y="1739646.0"/>
+            <a:ext cx="45720.0" cy="82296.0"/>
           </a:xfrm>
           <a:prstGeom prst="line">
             <a:avLst/>
@@ -3664,8 +3664,8 @@
         </p:nvCxnSpPr>
         <p:spPr>
           <a:xfrm flipV="1">
-            <a:off x="4892040.0" y="2404597.68"/>
-            <a:ext cx="22860.0" cy="21534.119999999646"/>
+            <a:off x="5440680.0" y="1657350.0"/>
+            <a:ext cx="45720.0" cy="82296.0"/>
           </a:xfrm>
           <a:prstGeom prst="line">
             <a:avLst/>
@@ -3699,8 +3699,8 @@
         </p:nvCxnSpPr>
         <p:spPr>
           <a:xfrm flipV="1">
-            <a:off x="4914900.0" y="2381554.8"/>
-            <a:ext cx="22860.0" cy="23042.880000000354"/>
+            <a:off x="5486400.0" y="1570482.0"/>
+            <a:ext cx="45720.0" cy="86868.0"/>
           </a:xfrm>
           <a:prstGeom prst="line">
             <a:avLst/>
@@ -3734,8 +3734,8 @@
         </p:nvCxnSpPr>
         <p:spPr>
           <a:xfrm flipV="1">
-            <a:off x="4937760.0" y="2357048.88"/>
-            <a:ext cx="22860.0" cy="24505.919999999925"/>
+            <a:off x="5532120.0" y="1479042.0"/>
+            <a:ext cx="45720.0" cy="91440.0"/>
           </a:xfrm>
           <a:prstGeom prst="line">
             <a:avLst/>
@@ -3769,8 +3769,8 @@
         </p:nvCxnSpPr>
         <p:spPr>
           <a:xfrm flipV="1">
-            <a:off x="4960620.0" y="2331034.2"/>
-            <a:ext cx="22860.0" cy="26014.679999999702"/>
+            <a:off x="5577840.0" y="1383030.0"/>
+            <a:ext cx="45720.0" cy="96012.0"/>
           </a:xfrm>
           <a:prstGeom prst="line">
             <a:avLst/>
@@ -3804,8 +3804,8 @@
         </p:nvCxnSpPr>
         <p:spPr>
           <a:xfrm flipV="1">
-            <a:off x="4983480.0" y="2303556.48"/>
-            <a:ext cx="22860.0" cy="27477.720000000205"/>
+            <a:off x="5623560.0" y="1282446.0"/>
+            <a:ext cx="45720.0" cy="100584.0"/>
           </a:xfrm>
           <a:prstGeom prst="line">
             <a:avLst/>
@@ -3839,8 +3839,8 @@
         </p:nvCxnSpPr>
         <p:spPr>
           <a:xfrm flipV="1">
-            <a:off x="5006340.0" y="2274570.0"/>
-            <a:ext cx="22860.0" cy="28986.47999999998"/>
+            <a:off x="5669280.0" y="1177290.0"/>
+            <a:ext cx="45720.0" cy="105156.0"/>
           </a:xfrm>
           <a:prstGeom prst="line">
             <a:avLst/>
@@ -3874,8 +3874,8 @@
         </p:nvCxnSpPr>
         <p:spPr>
           <a:xfrm flipV="1">
-            <a:off x="5029200.0" y="2244120.48"/>
-            <a:ext cx="22860.0" cy="30449.52000000002"/>
+            <a:off x="5715000.0" y="1067562.0"/>
+            <a:ext cx="45720.0" cy="109728.0"/>
           </a:xfrm>
           <a:prstGeom prst="line">
             <a:avLst/>
@@ -3909,8 +3909,8 @@
         </p:nvCxnSpPr>
         <p:spPr>
           <a:xfrm flipV="1">
-            <a:off x="5052060.0" y="2212162.2"/>
-            <a:ext cx="22860.0" cy="31958.279999999795"/>
+            <a:off x="5760720.0" y="953262.0"/>
+            <a:ext cx="45720.0" cy="114300.0"/>
           </a:xfrm>
           <a:prstGeom prst="line">
             <a:avLst/>
@@ -3944,8 +3944,8 @@
         </p:nvCxnSpPr>
         <p:spPr>
           <a:xfrm flipV="1">
-            <a:off x="5074920.0" y="2178740.88"/>
-            <a:ext cx="22860.0" cy="33421.3200000003"/>
+            <a:off x="5806440.0" y="834390.0"/>
+            <a:ext cx="45720.0" cy="118872.0"/>
           </a:xfrm>
           <a:prstGeom prst="line">
             <a:avLst/>
@@ -3979,8 +3979,8 @@
         </p:nvCxnSpPr>
         <p:spPr>
           <a:xfrm flipV="1">
-            <a:off x="5097780.0" y="2143810.8"/>
-            <a:ext cx="22860.0" cy="34930.080000000075"/>
+            <a:off x="5852160.0" y="710945.9999999998"/>
+            <a:ext cx="45720.0" cy="123444.00000000023"/>
           </a:xfrm>
           <a:prstGeom prst="line">
             <a:avLst/>
@@ -4014,8 +4014,8 @@
         </p:nvCxnSpPr>
         <p:spPr>
           <a:xfrm flipV="1">
-            <a:off x="5120640.0" y="2107417.68"/>
-            <a:ext cx="22860.0" cy="36393.119999999646"/>
+            <a:off x="5897880.0" y="578357.9999999998"/>
+            <a:ext cx="45720.0" cy="132588.0"/>
           </a:xfrm>
           <a:prstGeom prst="line">
             <a:avLst/>
@@ -4049,7 +4049,7 @@
         </p:nvSpPr>
         <p:spPr>
           <a:xfrm>
-            <a:off x="4991100" y="2236470"/>
+            <a:off x="5448300" y="1619250"/>
             <a:ext cx="76200" cy="76200"/>
           </a:xfrm>
           <a:prstGeom prst="ellipse">
@@ -4094,7 +4094,7 @@
         </p:nvSpPr>
         <p:spPr>
           <a:xfrm>
-            <a:off x="4572000" y="2571750"/>
+            <a:off x="4480560" y="2663190"/>
             <a:ext cx="635000" cy="254000"/>
           </a:xfrm>
           <a:prstGeom prst="rect">
@@ -4117,7 +4117,7 @@
               </a:defRPr>
             </a:pPr>
             <a:r>
-              <a:t>O</a:t>
+              <a:t>$O$</a:t>
             </a:r>
           </a:p>
         </p:txBody>
@@ -4130,7 +4130,7 @@
         </p:nvSpPr>
         <p:spPr>
           <a:xfrm>
-            <a:off x="5166360" y="2594610"/>
+            <a:off x="6035040" y="2708910"/>
             <a:ext cx="635000" cy="254000"/>
           </a:xfrm>
           <a:prstGeom prst="rect">
@@ -4153,7 +4153,7 @@
               </a:defRPr>
             </a:pPr>
             <a:r>
-              <a:t>x</a:t>
+              <a:t>$x$</a:t>
             </a:r>
           </a:p>
         </p:txBody>
@@ -4166,7 +4166,7 @@
         </p:nvSpPr>
         <p:spPr>
           <a:xfrm>
-            <a:off x="4549140" y="2068830"/>
+            <a:off x="4434840" y="742950"/>
             <a:ext cx="635000" cy="254000"/>
           </a:xfrm>
           <a:prstGeom prst="rect">
@@ -4189,7 +4189,7 @@
               </a:defRPr>
             </a:pPr>
             <a:r>
-              <a:t>y</a:t>
+              <a:t>$y$</a:t>
             </a:r>
           </a:p>
         </p:txBody>
@@ -4202,7 +4202,7 @@
         </p:nvSpPr>
         <p:spPr>
           <a:xfrm>
-            <a:off x="5029200" y="2594610"/>
+            <a:off x="5486400" y="2754630"/>
             <a:ext cx="635000" cy="254000"/>
           </a:xfrm>
           <a:prstGeom prst="rect">
@@ -4225,7 +4225,7 @@
               </a:defRPr>
             </a:pPr>
             <a:r>
-              <a:t>a</a:t>
+              <a:t>$a$</a:t>
             </a:r>
           </a:p>
         </p:txBody>
@@ -4238,7 +4238,7 @@
         </p:nvSpPr>
         <p:spPr>
           <a:xfrm>
-            <a:off x="4526280" y="2274570"/>
+            <a:off x="4343400" y="1657350"/>
             <a:ext cx="635000" cy="254000"/>
           </a:xfrm>
           <a:prstGeom prst="rect">
@@ -4274,7 +4274,7 @@
         </p:nvSpPr>
         <p:spPr>
           <a:xfrm>
-            <a:off x="5052060" y="2183130"/>
+            <a:off x="5760720" y="1200150"/>
             <a:ext cx="635000" cy="254000"/>
           </a:xfrm>
           <a:prstGeom prst="rect">

</xml_diff>

<commit_message>
fix: apply white theme to graphs and sync with premium root UI
</commit_message>
<xml_diff>
--- a/output/2.pptx
+++ b/output/2.pptx
@@ -3084,7 +3084,7 @@
     <p:bg>
       <p:bgPr>
         <a:solidFill>
-          <a:srgbClr val="1E1E23"/>
+          <a:srgbClr val="000000"/>
         </a:solidFill>
         <a:effectLst/>
       </p:bgPr>
@@ -3104,8 +3104,8 @@
         </p:nvCxnSpPr>
         <p:spPr>
           <a:xfrm>
-            <a:off x="4343400.0" y="2571750.0"/>
-            <a:ext cx="1508760.0" cy="0.0"/>
+            <a:off x="4297680.0" y="2571750.0"/>
+            <a:ext cx="1554480.0" cy="0.0"/>
           </a:xfrm>
           <a:prstGeom prst="line">
             <a:avLst/>
@@ -3139,8 +3139,8 @@
         </p:nvCxnSpPr>
         <p:spPr>
           <a:xfrm flipV="1">
-            <a:off x="4572000.0" y="1108710.0"/>
-            <a:ext cx="0.0" cy="1691640.0"/>
+            <a:off x="4572000.0" y="834390.0"/>
+            <a:ext cx="0.0" cy="1874520.0"/>
           </a:xfrm>
           <a:prstGeom prst="line">
             <a:avLst/>
@@ -3174,8 +3174,8 @@
         </p:nvSpPr>
         <p:spPr>
           <a:xfrm>
-            <a:off x="4389120" y="1017270"/>
-            <a:ext cx="1280160" cy="1139793"/>
+            <a:off x="4343400" y="971550"/>
+            <a:ext cx="1371600" cy="1141668"/>
           </a:xfrm>
           <a:custGeom>
             <a:avLst/>
@@ -3184,64 +3184,60 @@
             <a:cxnLst/>
             <a:rect l="l" t="t" r="r" b="b"/>
             <a:pathLst>
-              <a:path w="1280160" h="1139793">
+              <a:path w="1371600" h="1141668">
                 <a:moveTo>
                   <a:pt x="0" y="457200"/>
                 </a:moveTo>
                 <a:lnTo>
-                  <a:pt x="4281" y="461481"/>
-                </a:lnTo>
-                <a:close/>
-                <a:lnTo>
-                  <a:pt x="8563" y="465763"/>
-                </a:lnTo>
-                <a:close/>
-                <a:lnTo>
-                  <a:pt x="12844" y="470044"/>
-                </a:lnTo>
-                <a:close/>
-                <a:lnTo>
-                  <a:pt x="17126" y="474326"/>
-                </a:lnTo>
-                <a:close/>
-                <a:lnTo>
-                  <a:pt x="21407" y="478607"/>
-                </a:lnTo>
-                <a:close/>
-                <a:lnTo>
-                  <a:pt x="25689" y="482889"/>
-                </a:lnTo>
-                <a:close/>
-                <a:lnTo>
-                  <a:pt x="29970" y="487170"/>
-                </a:lnTo>
-                <a:close/>
-                <a:lnTo>
-                  <a:pt x="34252" y="491452"/>
-                </a:lnTo>
-                <a:close/>
-                <a:lnTo>
-                  <a:pt x="38533" y="495733"/>
-                </a:lnTo>
-                <a:close/>
-                <a:lnTo>
-                  <a:pt x="42815" y="500015"/>
-                </a:lnTo>
-                <a:close/>
-                <a:lnTo>
-                  <a:pt x="47096" y="504296"/>
-                </a:lnTo>
-                <a:close/>
-                <a:lnTo>
-                  <a:pt x="51378" y="508578"/>
-                </a:lnTo>
-                <a:close/>
-                <a:lnTo>
-                  <a:pt x="55659" y="512859"/>
-                </a:lnTo>
-                <a:close/>
-                <a:lnTo>
-                  <a:pt x="59941" y="517141"/>
+                  <a:pt x="4587" y="461787"/>
+                </a:lnTo>
+                <a:close/>
+                <a:lnTo>
+                  <a:pt x="9175" y="466375"/>
+                </a:lnTo>
+                <a:close/>
+                <a:lnTo>
+                  <a:pt x="13762" y="470962"/>
+                </a:lnTo>
+                <a:close/>
+                <a:lnTo>
+                  <a:pt x="18349" y="475549"/>
+                </a:lnTo>
+                <a:close/>
+                <a:lnTo>
+                  <a:pt x="22936" y="480136"/>
+                </a:lnTo>
+                <a:close/>
+                <a:lnTo>
+                  <a:pt x="27524" y="484724"/>
+                </a:lnTo>
+                <a:close/>
+                <a:lnTo>
+                  <a:pt x="32111" y="489311"/>
+                </a:lnTo>
+                <a:close/>
+                <a:lnTo>
+                  <a:pt x="36698" y="493898"/>
+                </a:lnTo>
+                <a:close/>
+                <a:lnTo>
+                  <a:pt x="41286" y="498486"/>
+                </a:lnTo>
+                <a:close/>
+                <a:lnTo>
+                  <a:pt x="45873" y="503073"/>
+                </a:lnTo>
+                <a:close/>
+                <a:lnTo>
+                  <a:pt x="50460" y="507660"/>
+                </a:lnTo>
+                <a:close/>
+                <a:lnTo>
+                  <a:pt x="55047" y="512247"/>
+                </a:lnTo>
+                <a:close/>
+                <a:lnTo>
+                  <a:pt x="59635" y="516835"/>
                 </a:lnTo>
                 <a:close/>
                 <a:lnTo>
@@ -3249,59 +3245,55 @@
                 </a:lnTo>
                 <a:close/>
                 <a:lnTo>
-                  <a:pt x="68504" y="525704"/>
-                </a:lnTo>
-                <a:close/>
-                <a:lnTo>
-                  <a:pt x="72785" y="529985"/>
-                </a:lnTo>
-                <a:close/>
-                <a:lnTo>
-                  <a:pt x="77066" y="534266"/>
-                </a:lnTo>
-                <a:close/>
-                <a:lnTo>
-                  <a:pt x="81348" y="538548"/>
-                </a:lnTo>
-                <a:close/>
-                <a:lnTo>
-                  <a:pt x="85629" y="542829"/>
-                </a:lnTo>
-                <a:close/>
-                <a:lnTo>
-                  <a:pt x="89911" y="547111"/>
-                </a:lnTo>
-                <a:close/>
-                <a:lnTo>
-                  <a:pt x="94192" y="551392"/>
-                </a:lnTo>
-                <a:close/>
-                <a:lnTo>
-                  <a:pt x="98474" y="555674"/>
-                </a:lnTo>
-                <a:close/>
-                <a:lnTo>
-                  <a:pt x="102755" y="559955"/>
-                </a:lnTo>
-                <a:close/>
-                <a:lnTo>
-                  <a:pt x="107037" y="564237"/>
-                </a:lnTo>
-                <a:close/>
-                <a:lnTo>
-                  <a:pt x="111318" y="568518"/>
-                </a:lnTo>
-                <a:close/>
-                <a:lnTo>
-                  <a:pt x="115600" y="572800"/>
-                </a:lnTo>
-                <a:close/>
-                <a:lnTo>
-                  <a:pt x="119881" y="577081"/>
-                </a:lnTo>
-                <a:close/>
-                <a:lnTo>
-                  <a:pt x="124163" y="581363"/>
+                  <a:pt x="68809" y="526009"/>
+                </a:lnTo>
+                <a:close/>
+                <a:lnTo>
+                  <a:pt x="73397" y="530597"/>
+                </a:lnTo>
+                <a:close/>
+                <a:lnTo>
+                  <a:pt x="77984" y="535184"/>
+                </a:lnTo>
+                <a:close/>
+                <a:lnTo>
+                  <a:pt x="82571" y="539771"/>
+                </a:lnTo>
+                <a:close/>
+                <a:lnTo>
+                  <a:pt x="87159" y="544359"/>
+                </a:lnTo>
+                <a:close/>
+                <a:lnTo>
+                  <a:pt x="91746" y="548946"/>
+                </a:lnTo>
+                <a:close/>
+                <a:lnTo>
+                  <a:pt x="96333" y="553533"/>
+                </a:lnTo>
+                <a:close/>
+                <a:lnTo>
+                  <a:pt x="100920" y="558120"/>
+                </a:lnTo>
+                <a:close/>
+                <a:lnTo>
+                  <a:pt x="105508" y="562708"/>
+                </a:lnTo>
+                <a:close/>
+                <a:lnTo>
+                  <a:pt x="110095" y="567295"/>
+                </a:lnTo>
+                <a:close/>
+                <a:lnTo>
+                  <a:pt x="114682" y="571882"/>
+                </a:lnTo>
+                <a:close/>
+                <a:lnTo>
+                  <a:pt x="119270" y="576470"/>
+                </a:lnTo>
+                <a:close/>
+                <a:lnTo>
+                  <a:pt x="123857" y="581057"/>
                 </a:lnTo>
                 <a:close/>
                 <a:lnTo>
@@ -3309,59 +3301,55 @@
                 </a:lnTo>
                 <a:close/>
                 <a:lnTo>
-                  <a:pt x="132726" y="589926"/>
-                </a:lnTo>
-                <a:close/>
-                <a:lnTo>
-                  <a:pt x="137007" y="594207"/>
-                </a:lnTo>
-                <a:close/>
-                <a:lnTo>
-                  <a:pt x="141289" y="598489"/>
-                </a:lnTo>
-                <a:close/>
-                <a:lnTo>
-                  <a:pt x="145570" y="602770"/>
-                </a:lnTo>
-                <a:close/>
-                <a:lnTo>
-                  <a:pt x="149852" y="607052"/>
-                </a:lnTo>
-                <a:close/>
-                <a:lnTo>
-                  <a:pt x="154133" y="611333"/>
-                </a:lnTo>
-                <a:close/>
-                <a:lnTo>
-                  <a:pt x="158414" y="615614"/>
-                </a:lnTo>
-                <a:close/>
-                <a:lnTo>
-                  <a:pt x="162696" y="619896"/>
-                </a:lnTo>
-                <a:close/>
-                <a:lnTo>
-                  <a:pt x="166977" y="624177"/>
-                </a:lnTo>
-                <a:close/>
-                <a:lnTo>
-                  <a:pt x="171259" y="628459"/>
-                </a:lnTo>
-                <a:close/>
-                <a:lnTo>
-                  <a:pt x="175540" y="632740"/>
-                </a:lnTo>
-                <a:close/>
-                <a:lnTo>
-                  <a:pt x="179822" y="637022"/>
-                </a:lnTo>
-                <a:close/>
-                <a:lnTo>
-                  <a:pt x="184103" y="641303"/>
-                </a:lnTo>
-                <a:close/>
-                <a:lnTo>
-                  <a:pt x="188385" y="645585"/>
+                  <a:pt x="133031" y="590231"/>
+                </a:lnTo>
+                <a:close/>
+                <a:lnTo>
+                  <a:pt x="137619" y="594819"/>
+                </a:lnTo>
+                <a:close/>
+                <a:lnTo>
+                  <a:pt x="142206" y="599406"/>
+                </a:lnTo>
+                <a:close/>
+                <a:lnTo>
+                  <a:pt x="146793" y="603993"/>
+                </a:lnTo>
+                <a:close/>
+                <a:lnTo>
+                  <a:pt x="151381" y="608581"/>
+                </a:lnTo>
+                <a:close/>
+                <a:lnTo>
+                  <a:pt x="155968" y="613168"/>
+                </a:lnTo>
+                <a:close/>
+                <a:lnTo>
+                  <a:pt x="160555" y="617755"/>
+                </a:lnTo>
+                <a:close/>
+                <a:lnTo>
+                  <a:pt x="165142" y="622342"/>
+                </a:lnTo>
+                <a:close/>
+                <a:lnTo>
+                  <a:pt x="169730" y="626930"/>
+                </a:lnTo>
+                <a:close/>
+                <a:lnTo>
+                  <a:pt x="174317" y="631517"/>
+                </a:lnTo>
+                <a:close/>
+                <a:lnTo>
+                  <a:pt x="178904" y="636104"/>
+                </a:lnTo>
+                <a:close/>
+                <a:lnTo>
+                  <a:pt x="183492" y="640692"/>
+                </a:lnTo>
+                <a:close/>
+                <a:lnTo>
+                  <a:pt x="188079" y="645279"/>
                 </a:lnTo>
                 <a:close/>
                 <a:lnTo>
@@ -3369,59 +3357,55 @@
                 </a:lnTo>
                 <a:close/>
                 <a:lnTo>
-                  <a:pt x="196948" y="654148"/>
-                </a:lnTo>
-                <a:close/>
-                <a:lnTo>
-                  <a:pt x="201229" y="658429"/>
-                </a:lnTo>
-                <a:close/>
-                <a:lnTo>
-                  <a:pt x="205511" y="662711"/>
-                </a:lnTo>
-                <a:close/>
-                <a:lnTo>
-                  <a:pt x="209792" y="666992"/>
-                </a:lnTo>
-                <a:close/>
-                <a:lnTo>
-                  <a:pt x="214074" y="671274"/>
-                </a:lnTo>
-                <a:close/>
-                <a:lnTo>
-                  <a:pt x="218355" y="675555"/>
-                </a:lnTo>
-                <a:close/>
-                <a:lnTo>
-                  <a:pt x="222637" y="679837"/>
-                </a:lnTo>
-                <a:close/>
-                <a:lnTo>
-                  <a:pt x="226918" y="684118"/>
-                </a:lnTo>
-                <a:close/>
-                <a:lnTo>
-                  <a:pt x="231199" y="688399"/>
-                </a:lnTo>
-                <a:close/>
-                <a:lnTo>
-                  <a:pt x="235481" y="692681"/>
-                </a:lnTo>
-                <a:close/>
-                <a:lnTo>
-                  <a:pt x="239762" y="696962"/>
-                </a:lnTo>
-                <a:close/>
-                <a:lnTo>
-                  <a:pt x="244044" y="701244"/>
-                </a:lnTo>
-                <a:close/>
-                <a:lnTo>
-                  <a:pt x="248325" y="705525"/>
-                </a:lnTo>
-                <a:close/>
-                <a:lnTo>
-                  <a:pt x="252607" y="709807"/>
+                  <a:pt x="197254" y="654454"/>
+                </a:lnTo>
+                <a:close/>
+                <a:lnTo>
+                  <a:pt x="201841" y="659041"/>
+                </a:lnTo>
+                <a:close/>
+                <a:lnTo>
+                  <a:pt x="206428" y="663628"/>
+                </a:lnTo>
+                <a:close/>
+                <a:lnTo>
+                  <a:pt x="211015" y="668215"/>
+                </a:lnTo>
+                <a:close/>
+                <a:lnTo>
+                  <a:pt x="215603" y="672803"/>
+                </a:lnTo>
+                <a:close/>
+                <a:lnTo>
+                  <a:pt x="220190" y="677390"/>
+                </a:lnTo>
+                <a:close/>
+                <a:lnTo>
+                  <a:pt x="224777" y="681977"/>
+                </a:lnTo>
+                <a:close/>
+                <a:lnTo>
+                  <a:pt x="229365" y="686565"/>
+                </a:lnTo>
+                <a:close/>
+                <a:lnTo>
+                  <a:pt x="233952" y="691152"/>
+                </a:lnTo>
+                <a:close/>
+                <a:lnTo>
+                  <a:pt x="238539" y="695739"/>
+                </a:lnTo>
+                <a:close/>
+                <a:lnTo>
+                  <a:pt x="243126" y="700326"/>
+                </a:lnTo>
+                <a:close/>
+                <a:lnTo>
+                  <a:pt x="247714" y="704914"/>
+                </a:lnTo>
+                <a:close/>
+                <a:lnTo>
+                  <a:pt x="252301" y="709501"/>
                 </a:lnTo>
                 <a:close/>
                 <a:lnTo>
@@ -3429,59 +3413,55 @@
                 </a:lnTo>
                 <a:close/>
                 <a:lnTo>
-                  <a:pt x="261170" y="718370"/>
-                </a:lnTo>
-                <a:close/>
-                <a:lnTo>
-                  <a:pt x="265451" y="722651"/>
-                </a:lnTo>
-                <a:close/>
-                <a:lnTo>
-                  <a:pt x="269733" y="726933"/>
-                </a:lnTo>
-                <a:close/>
-                <a:lnTo>
-                  <a:pt x="274014" y="731214"/>
-                </a:lnTo>
-                <a:close/>
-                <a:lnTo>
-                  <a:pt x="278296" y="735496"/>
-                </a:lnTo>
-                <a:close/>
-                <a:lnTo>
-                  <a:pt x="282577" y="739777"/>
-                </a:lnTo>
-                <a:close/>
-                <a:lnTo>
-                  <a:pt x="286859" y="744059"/>
-                </a:lnTo>
-                <a:close/>
-                <a:lnTo>
-                  <a:pt x="291140" y="748340"/>
-                </a:lnTo>
-                <a:close/>
-                <a:lnTo>
-                  <a:pt x="295422" y="752622"/>
-                </a:lnTo>
-                <a:close/>
-                <a:lnTo>
-                  <a:pt x="299703" y="756903"/>
-                </a:lnTo>
-                <a:close/>
-                <a:lnTo>
-                  <a:pt x="303984" y="761184"/>
-                </a:lnTo>
-                <a:close/>
-                <a:lnTo>
-                  <a:pt x="308266" y="765466"/>
-                </a:lnTo>
-                <a:close/>
-                <a:lnTo>
-                  <a:pt x="312547" y="769747"/>
-                </a:lnTo>
-                <a:close/>
-                <a:lnTo>
-                  <a:pt x="316829" y="774029"/>
+                  <a:pt x="261476" y="718676"/>
+                </a:lnTo>
+                <a:close/>
+                <a:lnTo>
+                  <a:pt x="266063" y="723263"/>
+                </a:lnTo>
+                <a:close/>
+                <a:lnTo>
+                  <a:pt x="270650" y="727850"/>
+                </a:lnTo>
+                <a:close/>
+                <a:lnTo>
+                  <a:pt x="275237" y="732437"/>
+                </a:lnTo>
+                <a:close/>
+                <a:lnTo>
+                  <a:pt x="279825" y="737025"/>
+                </a:lnTo>
+                <a:close/>
+                <a:lnTo>
+                  <a:pt x="284412" y="741612"/>
+                </a:lnTo>
+                <a:close/>
+                <a:lnTo>
+                  <a:pt x="288999" y="746199"/>
+                </a:lnTo>
+                <a:close/>
+                <a:lnTo>
+                  <a:pt x="293587" y="750787"/>
+                </a:lnTo>
+                <a:close/>
+                <a:lnTo>
+                  <a:pt x="298174" y="755374"/>
+                </a:lnTo>
+                <a:close/>
+                <a:lnTo>
+                  <a:pt x="302761" y="759961"/>
+                </a:lnTo>
+                <a:close/>
+                <a:lnTo>
+                  <a:pt x="307348" y="764548"/>
+                </a:lnTo>
+                <a:close/>
+                <a:lnTo>
+                  <a:pt x="311936" y="769136"/>
+                </a:lnTo>
+                <a:close/>
+                <a:lnTo>
+                  <a:pt x="316523" y="773723"/>
                 </a:lnTo>
                 <a:close/>
                 <a:lnTo>
@@ -3489,59 +3469,55 @@
                 </a:lnTo>
                 <a:close/>
                 <a:lnTo>
-                  <a:pt x="325392" y="782592"/>
-                </a:lnTo>
-                <a:close/>
-                <a:lnTo>
-                  <a:pt x="329673" y="786873"/>
-                </a:lnTo>
-                <a:close/>
-                <a:lnTo>
-                  <a:pt x="333955" y="791155"/>
-                </a:lnTo>
-                <a:close/>
-                <a:lnTo>
-                  <a:pt x="338236" y="795436"/>
-                </a:lnTo>
-                <a:close/>
-                <a:lnTo>
-                  <a:pt x="342518" y="799718"/>
-                </a:lnTo>
-                <a:close/>
-                <a:lnTo>
-                  <a:pt x="346799" y="803999"/>
-                </a:lnTo>
-                <a:close/>
-                <a:lnTo>
-                  <a:pt x="351081" y="808281"/>
-                </a:lnTo>
-                <a:close/>
-                <a:lnTo>
-                  <a:pt x="355362" y="812562"/>
-                </a:lnTo>
-                <a:close/>
-                <a:lnTo>
-                  <a:pt x="359644" y="816844"/>
-                </a:lnTo>
-                <a:close/>
-                <a:lnTo>
-                  <a:pt x="363925" y="821125"/>
-                </a:lnTo>
-                <a:close/>
-                <a:lnTo>
-                  <a:pt x="368207" y="825407"/>
-                </a:lnTo>
-                <a:close/>
-                <a:lnTo>
-                  <a:pt x="372488" y="829688"/>
-                </a:lnTo>
-                <a:close/>
-                <a:lnTo>
-                  <a:pt x="376769" y="833969"/>
-                </a:lnTo>
-                <a:close/>
-                <a:lnTo>
-                  <a:pt x="381051" y="838251"/>
+                  <a:pt x="325698" y="782898"/>
+                </a:lnTo>
+                <a:close/>
+                <a:lnTo>
+                  <a:pt x="330285" y="787485"/>
+                </a:lnTo>
+                <a:close/>
+                <a:lnTo>
+                  <a:pt x="334872" y="792072"/>
+                </a:lnTo>
+                <a:close/>
+                <a:lnTo>
+                  <a:pt x="339460" y="796660"/>
+                </a:lnTo>
+                <a:close/>
+                <a:lnTo>
+                  <a:pt x="344047" y="801247"/>
+                </a:lnTo>
+                <a:close/>
+                <a:lnTo>
+                  <a:pt x="348634" y="805834"/>
+                </a:lnTo>
+                <a:close/>
+                <a:lnTo>
+                  <a:pt x="353221" y="810421"/>
+                </a:lnTo>
+                <a:close/>
+                <a:lnTo>
+                  <a:pt x="357809" y="815009"/>
+                </a:lnTo>
+                <a:close/>
+                <a:lnTo>
+                  <a:pt x="362396" y="819596"/>
+                </a:lnTo>
+                <a:close/>
+                <a:lnTo>
+                  <a:pt x="366983" y="824183"/>
+                </a:lnTo>
+                <a:close/>
+                <a:lnTo>
+                  <a:pt x="371571" y="828771"/>
+                </a:lnTo>
+                <a:close/>
+                <a:lnTo>
+                  <a:pt x="376158" y="833358"/>
+                </a:lnTo>
+                <a:close/>
+                <a:lnTo>
+                  <a:pt x="380745" y="837945"/>
                 </a:lnTo>
                 <a:close/>
                 <a:lnTo>
@@ -3549,59 +3525,55 @@
                 </a:lnTo>
                 <a:close/>
                 <a:lnTo>
-                  <a:pt x="389614" y="846814"/>
-                </a:lnTo>
-                <a:close/>
-                <a:lnTo>
-                  <a:pt x="393895" y="851095"/>
-                </a:lnTo>
-                <a:close/>
-                <a:lnTo>
-                  <a:pt x="398177" y="855377"/>
-                </a:lnTo>
-                <a:close/>
-                <a:lnTo>
-                  <a:pt x="402458" y="859658"/>
-                </a:lnTo>
-                <a:close/>
-                <a:lnTo>
-                  <a:pt x="406740" y="863940"/>
-                </a:lnTo>
-                <a:close/>
-                <a:lnTo>
-                  <a:pt x="411021" y="868221"/>
-                </a:lnTo>
-                <a:close/>
-                <a:lnTo>
-                  <a:pt x="415303" y="872503"/>
-                </a:lnTo>
-                <a:close/>
-                <a:lnTo>
-                  <a:pt x="419584" y="876784"/>
-                </a:lnTo>
-                <a:close/>
-                <a:lnTo>
-                  <a:pt x="423866" y="881066"/>
-                </a:lnTo>
-                <a:close/>
-                <a:lnTo>
-                  <a:pt x="428147" y="885347"/>
-                </a:lnTo>
-                <a:close/>
-                <a:lnTo>
-                  <a:pt x="432429" y="889629"/>
-                </a:lnTo>
-                <a:close/>
-                <a:lnTo>
-                  <a:pt x="436710" y="893910"/>
-                </a:lnTo>
-                <a:close/>
-                <a:lnTo>
-                  <a:pt x="440992" y="898192"/>
-                </a:lnTo>
-                <a:close/>
-                <a:lnTo>
-                  <a:pt x="445273" y="902473"/>
+                  <a:pt x="389920" y="847120"/>
+                </a:lnTo>
+                <a:close/>
+                <a:lnTo>
+                  <a:pt x="394507" y="851707"/>
+                </a:lnTo>
+                <a:close/>
+                <a:lnTo>
+                  <a:pt x="399094" y="856294"/>
+                </a:lnTo>
+                <a:close/>
+                <a:lnTo>
+                  <a:pt x="403682" y="860882"/>
+                </a:lnTo>
+                <a:close/>
+                <a:lnTo>
+                  <a:pt x="408269" y="865469"/>
+                </a:lnTo>
+                <a:close/>
+                <a:lnTo>
+                  <a:pt x="412856" y="870056"/>
+                </a:lnTo>
+                <a:close/>
+                <a:lnTo>
+                  <a:pt x="417443" y="874643"/>
+                </a:lnTo>
+                <a:close/>
+                <a:lnTo>
+                  <a:pt x="422031" y="879231"/>
+                </a:lnTo>
+                <a:close/>
+                <a:lnTo>
+                  <a:pt x="426618" y="883818"/>
+                </a:lnTo>
+                <a:close/>
+                <a:lnTo>
+                  <a:pt x="431205" y="888405"/>
+                </a:lnTo>
+                <a:close/>
+                <a:lnTo>
+                  <a:pt x="435793" y="892993"/>
+                </a:lnTo>
+                <a:close/>
+                <a:lnTo>
+                  <a:pt x="440380" y="897580"/>
+                </a:lnTo>
+                <a:close/>
+                <a:lnTo>
+                  <a:pt x="444967" y="902167"/>
                 </a:lnTo>
                 <a:close/>
                 <a:lnTo>
@@ -3609,59 +3581,55 @@
                 </a:lnTo>
                 <a:close/>
                 <a:lnTo>
-                  <a:pt x="453836" y="911036"/>
-                </a:lnTo>
-                <a:close/>
-                <a:lnTo>
-                  <a:pt x="458117" y="915317"/>
-                </a:lnTo>
-                <a:close/>
-                <a:lnTo>
-                  <a:pt x="462399" y="919599"/>
-                </a:lnTo>
-                <a:close/>
-                <a:lnTo>
-                  <a:pt x="466680" y="923880"/>
-                </a:lnTo>
-                <a:close/>
-                <a:lnTo>
-                  <a:pt x="470962" y="928162"/>
-                </a:lnTo>
-                <a:close/>
-                <a:lnTo>
-                  <a:pt x="475243" y="932443"/>
-                </a:lnTo>
-                <a:close/>
-                <a:lnTo>
-                  <a:pt x="479525" y="936725"/>
-                </a:lnTo>
-                <a:close/>
-                <a:lnTo>
-                  <a:pt x="483806" y="941006"/>
-                </a:lnTo>
-                <a:close/>
-                <a:lnTo>
-                  <a:pt x="488088" y="945288"/>
-                </a:lnTo>
-                <a:close/>
-                <a:lnTo>
-                  <a:pt x="492369" y="949569"/>
-                </a:lnTo>
-                <a:close/>
-                <a:lnTo>
-                  <a:pt x="496651" y="953851"/>
-                </a:lnTo>
-                <a:close/>
-                <a:lnTo>
-                  <a:pt x="500932" y="958132"/>
-                </a:lnTo>
-                <a:close/>
-                <a:lnTo>
-                  <a:pt x="505214" y="962414"/>
-                </a:lnTo>
-                <a:close/>
-                <a:lnTo>
-                  <a:pt x="509495" y="966695"/>
+                  <a:pt x="454142" y="911342"/>
+                </a:lnTo>
+                <a:close/>
+                <a:lnTo>
+                  <a:pt x="458729" y="915929"/>
+                </a:lnTo>
+                <a:close/>
+                <a:lnTo>
+                  <a:pt x="463316" y="920516"/>
+                </a:lnTo>
+                <a:close/>
+                <a:lnTo>
+                  <a:pt x="467904" y="925104"/>
+                </a:lnTo>
+                <a:close/>
+                <a:lnTo>
+                  <a:pt x="472491" y="929691"/>
+                </a:lnTo>
+                <a:close/>
+                <a:lnTo>
+                  <a:pt x="477078" y="934278"/>
+                </a:lnTo>
+                <a:close/>
+                <a:lnTo>
+                  <a:pt x="481666" y="938866"/>
+                </a:lnTo>
+                <a:close/>
+                <a:lnTo>
+                  <a:pt x="486253" y="943453"/>
+                </a:lnTo>
+                <a:close/>
+                <a:lnTo>
+                  <a:pt x="490840" y="948040"/>
+                </a:lnTo>
+                <a:close/>
+                <a:lnTo>
+                  <a:pt x="495427" y="952627"/>
+                </a:lnTo>
+                <a:close/>
+                <a:lnTo>
+                  <a:pt x="500015" y="957215"/>
+                </a:lnTo>
+                <a:close/>
+                <a:lnTo>
+                  <a:pt x="504602" y="961802"/>
+                </a:lnTo>
+                <a:close/>
+                <a:lnTo>
+                  <a:pt x="509189" y="966389"/>
                 </a:lnTo>
                 <a:close/>
                 <a:lnTo>
@@ -3669,59 +3637,55 @@
                 </a:lnTo>
                 <a:close/>
                 <a:lnTo>
-                  <a:pt x="518058" y="975258"/>
-                </a:lnTo>
-                <a:close/>
-                <a:lnTo>
-                  <a:pt x="522340" y="979540"/>
-                </a:lnTo>
-                <a:close/>
-                <a:lnTo>
-                  <a:pt x="526621" y="983821"/>
-                </a:lnTo>
-                <a:close/>
-                <a:lnTo>
-                  <a:pt x="530902" y="988102"/>
-                </a:lnTo>
-                <a:close/>
-                <a:lnTo>
-                  <a:pt x="535184" y="992384"/>
-                </a:lnTo>
-                <a:close/>
-                <a:lnTo>
-                  <a:pt x="539465" y="996665"/>
-                </a:lnTo>
-                <a:close/>
-                <a:lnTo>
-                  <a:pt x="543747" y="1000947"/>
-                </a:lnTo>
-                <a:close/>
-                <a:lnTo>
-                  <a:pt x="548028" y="1005228"/>
-                </a:lnTo>
-                <a:close/>
-                <a:lnTo>
-                  <a:pt x="552310" y="1009510"/>
-                </a:lnTo>
-                <a:close/>
-                <a:lnTo>
-                  <a:pt x="556591" y="1013791"/>
-                </a:lnTo>
-                <a:close/>
-                <a:lnTo>
-                  <a:pt x="560873" y="1018073"/>
-                </a:lnTo>
-                <a:close/>
-                <a:lnTo>
-                  <a:pt x="565154" y="1022354"/>
-                </a:lnTo>
-                <a:close/>
-                <a:lnTo>
-                  <a:pt x="569436" y="1026636"/>
-                </a:lnTo>
-                <a:close/>
-                <a:lnTo>
-                  <a:pt x="573717" y="1030917"/>
+                  <a:pt x="518364" y="975564"/>
+                </a:lnTo>
+                <a:close/>
+                <a:lnTo>
+                  <a:pt x="522951" y="980151"/>
+                </a:lnTo>
+                <a:close/>
+                <a:lnTo>
+                  <a:pt x="527538" y="984738"/>
+                </a:lnTo>
+                <a:close/>
+                <a:lnTo>
+                  <a:pt x="532126" y="989326"/>
+                </a:lnTo>
+                <a:close/>
+                <a:lnTo>
+                  <a:pt x="536713" y="993913"/>
+                </a:lnTo>
+                <a:close/>
+                <a:lnTo>
+                  <a:pt x="541300" y="998500"/>
+                </a:lnTo>
+                <a:close/>
+                <a:lnTo>
+                  <a:pt x="545888" y="1003088"/>
+                </a:lnTo>
+                <a:close/>
+                <a:lnTo>
+                  <a:pt x="550475" y="1007675"/>
+                </a:lnTo>
+                <a:close/>
+                <a:lnTo>
+                  <a:pt x="555062" y="1012262"/>
+                </a:lnTo>
+                <a:close/>
+                <a:lnTo>
+                  <a:pt x="559649" y="1016849"/>
+                </a:lnTo>
+                <a:close/>
+                <a:lnTo>
+                  <a:pt x="564237" y="1021437"/>
+                </a:lnTo>
+                <a:close/>
+                <a:lnTo>
+                  <a:pt x="568824" y="1026024"/>
+                </a:lnTo>
+                <a:close/>
+                <a:lnTo>
+                  <a:pt x="573411" y="1030611"/>
                 </a:lnTo>
                 <a:close/>
                 <a:lnTo>
@@ -3729,659 +3693,695 @@
                 </a:lnTo>
                 <a:close/>
                 <a:lnTo>
-                  <a:pt x="582280" y="1039480"/>
-                </a:lnTo>
-                <a:close/>
-                <a:lnTo>
-                  <a:pt x="586562" y="1043762"/>
-                </a:lnTo>
-                <a:close/>
-                <a:lnTo>
-                  <a:pt x="590843" y="1048043"/>
-                </a:lnTo>
-                <a:close/>
-                <a:lnTo>
-                  <a:pt x="595125" y="1052325"/>
-                </a:lnTo>
-                <a:close/>
-                <a:lnTo>
-                  <a:pt x="599406" y="1056605"/>
-                </a:lnTo>
-                <a:close/>
-                <a:lnTo>
-                  <a:pt x="603687" y="1060889"/>
-                </a:lnTo>
-                <a:close/>
-                <a:lnTo>
-                  <a:pt x="607969" y="1065171"/>
-                </a:lnTo>
-                <a:close/>
-                <a:lnTo>
-                  <a:pt x="612250" y="1069421"/>
-                </a:lnTo>
-                <a:close/>
-                <a:lnTo>
-                  <a:pt x="616532" y="1073901"/>
-                </a:lnTo>
-                <a:close/>
-                <a:lnTo>
-                  <a:pt x="620813" y="1077226"/>
-                </a:lnTo>
-                <a:close/>
-                <a:lnTo>
-                  <a:pt x="625095" y="1085606"/>
-                </a:lnTo>
-                <a:close/>
-                <a:lnTo>
-                  <a:pt x="629376" y="1073535"/>
-                </a:lnTo>
-                <a:close/>
-                <a:lnTo>
-                  <a:pt x="633658" y="1139793"/>
-                </a:lnTo>
-                <a:close/>
-                <a:lnTo>
-                  <a:pt x="637939" y="850113"/>
-                </a:lnTo>
-                <a:close/>
-                <a:lnTo>
-                  <a:pt x="642221" y="591254"/>
-                </a:lnTo>
-                <a:close/>
-                <a:lnTo>
-                  <a:pt x="646502" y="646618"/>
-                </a:lnTo>
-                <a:close/>
-                <a:lnTo>
-                  <a:pt x="650784" y="625922"/>
-                </a:lnTo>
-                <a:close/>
-                <a:lnTo>
-                  <a:pt x="655065" y="625972"/>
-                </a:lnTo>
-                <a:close/>
-                <a:lnTo>
-                  <a:pt x="659347" y="620605"/>
-                </a:lnTo>
-                <a:close/>
-                <a:lnTo>
-                  <a:pt x="663628" y="616577"/>
-                </a:lnTo>
-                <a:close/>
-                <a:lnTo>
-                  <a:pt x="667910" y="612243"/>
-                </a:lnTo>
-                <a:close/>
-                <a:lnTo>
-                  <a:pt x="672191" y="607970"/>
-                </a:lnTo>
-                <a:close/>
-                <a:lnTo>
-                  <a:pt x="676473" y="603688"/>
-                </a:lnTo>
-                <a:close/>
-                <a:lnTo>
-                  <a:pt x="680754" y="599406"/>
-                </a:lnTo>
-                <a:close/>
-                <a:lnTo>
-                  <a:pt x="685035" y="595125"/>
-                </a:lnTo>
-                <a:close/>
-                <a:lnTo>
-                  <a:pt x="689317" y="590843"/>
-                </a:lnTo>
-                <a:close/>
-                <a:lnTo>
-                  <a:pt x="693598" y="586562"/>
-                </a:lnTo>
-                <a:close/>
-                <a:lnTo>
-                  <a:pt x="697880" y="582280"/>
-                </a:lnTo>
-                <a:close/>
-                <a:lnTo>
-                  <a:pt x="702161" y="577999"/>
-                </a:lnTo>
-                <a:close/>
-                <a:lnTo>
-                  <a:pt x="706443" y="573717"/>
-                </a:lnTo>
-                <a:close/>
-                <a:lnTo>
-                  <a:pt x="710724" y="569436"/>
-                </a:lnTo>
-                <a:close/>
-                <a:lnTo>
-                  <a:pt x="715006" y="565154"/>
-                </a:lnTo>
-                <a:close/>
-                <a:lnTo>
-                  <a:pt x="719287" y="560873"/>
-                </a:lnTo>
-                <a:close/>
-                <a:lnTo>
-                  <a:pt x="723569" y="556591"/>
-                </a:lnTo>
-                <a:close/>
-                <a:lnTo>
-                  <a:pt x="727850" y="552310"/>
-                </a:lnTo>
-                <a:close/>
-                <a:lnTo>
-                  <a:pt x="732132" y="548028"/>
-                </a:lnTo>
-                <a:close/>
-                <a:lnTo>
-                  <a:pt x="736413" y="543747"/>
-                </a:lnTo>
-                <a:close/>
-                <a:lnTo>
-                  <a:pt x="740695" y="539465"/>
-                </a:lnTo>
-                <a:close/>
-                <a:lnTo>
-                  <a:pt x="744976" y="535184"/>
-                </a:lnTo>
-                <a:close/>
-                <a:lnTo>
-                  <a:pt x="749258" y="530902"/>
-                </a:lnTo>
-                <a:close/>
-                <a:lnTo>
-                  <a:pt x="753539" y="526621"/>
-                </a:lnTo>
-                <a:close/>
-                <a:lnTo>
-                  <a:pt x="757820" y="522340"/>
-                </a:lnTo>
-                <a:close/>
-                <a:lnTo>
-                  <a:pt x="762102" y="518058"/>
-                </a:lnTo>
-                <a:close/>
-                <a:lnTo>
-                  <a:pt x="766383" y="513777"/>
-                </a:lnTo>
-                <a:close/>
-                <a:lnTo>
-                  <a:pt x="770665" y="509495"/>
-                </a:lnTo>
-                <a:close/>
-                <a:lnTo>
-                  <a:pt x="774946" y="505214"/>
-                </a:lnTo>
-                <a:close/>
-                <a:lnTo>
-                  <a:pt x="779228" y="500932"/>
-                </a:lnTo>
-                <a:close/>
-                <a:lnTo>
-                  <a:pt x="783509" y="496651"/>
-                </a:lnTo>
-                <a:close/>
-                <a:lnTo>
-                  <a:pt x="787791" y="492369"/>
-                </a:lnTo>
-                <a:close/>
-                <a:lnTo>
-                  <a:pt x="792072" y="488088"/>
-                </a:lnTo>
-                <a:close/>
-                <a:lnTo>
-                  <a:pt x="796354" y="483806"/>
-                </a:lnTo>
-                <a:close/>
-                <a:lnTo>
-                  <a:pt x="800635" y="479525"/>
-                </a:lnTo>
-                <a:close/>
-                <a:lnTo>
-                  <a:pt x="804917" y="475243"/>
-                </a:lnTo>
-                <a:close/>
-                <a:lnTo>
-                  <a:pt x="809198" y="470962"/>
-                </a:lnTo>
-                <a:close/>
-                <a:lnTo>
-                  <a:pt x="813480" y="466680"/>
-                </a:lnTo>
-                <a:close/>
-                <a:lnTo>
-                  <a:pt x="817761" y="462399"/>
-                </a:lnTo>
-                <a:close/>
-                <a:lnTo>
-                  <a:pt x="822043" y="458117"/>
-                </a:lnTo>
-                <a:close/>
-                <a:lnTo>
-                  <a:pt x="826324" y="453836"/>
-                </a:lnTo>
-                <a:close/>
-                <a:lnTo>
-                  <a:pt x="830605" y="449555"/>
-                </a:lnTo>
-                <a:close/>
-                <a:lnTo>
-                  <a:pt x="834887" y="445273"/>
-                </a:lnTo>
-                <a:close/>
-                <a:lnTo>
-                  <a:pt x="839168" y="440992"/>
-                </a:lnTo>
-                <a:close/>
-                <a:lnTo>
-                  <a:pt x="843450" y="436710"/>
-                </a:lnTo>
-                <a:close/>
-                <a:lnTo>
-                  <a:pt x="847731" y="432429"/>
-                </a:lnTo>
-                <a:close/>
-                <a:lnTo>
-                  <a:pt x="852013" y="428147"/>
-                </a:lnTo>
-                <a:close/>
-                <a:lnTo>
-                  <a:pt x="856294" y="423866"/>
-                </a:lnTo>
-                <a:close/>
-                <a:lnTo>
-                  <a:pt x="860576" y="419584"/>
-                </a:lnTo>
-                <a:close/>
-                <a:lnTo>
-                  <a:pt x="864857" y="415303"/>
-                </a:lnTo>
-                <a:close/>
-                <a:lnTo>
-                  <a:pt x="869139" y="411021"/>
-                </a:lnTo>
-                <a:close/>
-                <a:lnTo>
-                  <a:pt x="873420" y="406740"/>
-                </a:lnTo>
-                <a:close/>
-                <a:lnTo>
-                  <a:pt x="877702" y="402458"/>
-                </a:lnTo>
-                <a:close/>
-                <a:lnTo>
-                  <a:pt x="881983" y="398177"/>
-                </a:lnTo>
-                <a:close/>
-                <a:lnTo>
-                  <a:pt x="886265" y="393895"/>
-                </a:lnTo>
-                <a:close/>
-                <a:lnTo>
-                  <a:pt x="890546" y="389614"/>
-                </a:lnTo>
-                <a:close/>
-                <a:lnTo>
-                  <a:pt x="894828" y="385332"/>
-                </a:lnTo>
-                <a:close/>
-                <a:lnTo>
-                  <a:pt x="899109" y="381051"/>
-                </a:lnTo>
-                <a:close/>
-                <a:lnTo>
-                  <a:pt x="903391" y="376769"/>
-                </a:lnTo>
-                <a:close/>
-                <a:lnTo>
-                  <a:pt x="907672" y="372488"/>
-                </a:lnTo>
-                <a:close/>
-                <a:lnTo>
-                  <a:pt x="911953" y="368207"/>
-                </a:lnTo>
-                <a:close/>
-                <a:lnTo>
-                  <a:pt x="916235" y="363925"/>
-                </a:lnTo>
-                <a:close/>
-                <a:lnTo>
-                  <a:pt x="920516" y="359644"/>
-                </a:lnTo>
-                <a:close/>
-                <a:lnTo>
-                  <a:pt x="924798" y="355362"/>
-                </a:lnTo>
-                <a:close/>
-                <a:lnTo>
-                  <a:pt x="929079" y="351081"/>
-                </a:lnTo>
-                <a:close/>
-                <a:lnTo>
-                  <a:pt x="933361" y="346799"/>
-                </a:lnTo>
-                <a:close/>
-                <a:lnTo>
-                  <a:pt x="937642" y="342518"/>
-                </a:lnTo>
-                <a:close/>
-                <a:lnTo>
-                  <a:pt x="941924" y="338236"/>
-                </a:lnTo>
-                <a:close/>
-                <a:lnTo>
-                  <a:pt x="946205" y="333955"/>
-                </a:lnTo>
-                <a:close/>
-                <a:lnTo>
-                  <a:pt x="950487" y="329673"/>
-                </a:lnTo>
-                <a:close/>
-                <a:lnTo>
-                  <a:pt x="954768" y="325392"/>
-                </a:lnTo>
-                <a:close/>
-                <a:lnTo>
-                  <a:pt x="959050" y="321110"/>
-                </a:lnTo>
-                <a:close/>
-                <a:lnTo>
-                  <a:pt x="963331" y="316829"/>
-                </a:lnTo>
-                <a:close/>
-                <a:lnTo>
-                  <a:pt x="967613" y="312547"/>
-                </a:lnTo>
-                <a:close/>
-                <a:lnTo>
-                  <a:pt x="971894" y="308266"/>
-                </a:lnTo>
-                <a:close/>
-                <a:lnTo>
-                  <a:pt x="976176" y="303984"/>
-                </a:lnTo>
-                <a:close/>
-                <a:lnTo>
-                  <a:pt x="980457" y="299703"/>
-                </a:lnTo>
-                <a:close/>
-                <a:lnTo>
-                  <a:pt x="984738" y="295422"/>
-                </a:lnTo>
-                <a:close/>
-                <a:lnTo>
-                  <a:pt x="989020" y="291140"/>
-                </a:lnTo>
-                <a:close/>
-                <a:lnTo>
-                  <a:pt x="993301" y="286859"/>
-                </a:lnTo>
-                <a:close/>
-                <a:lnTo>
-                  <a:pt x="997583" y="282577"/>
-                </a:lnTo>
-                <a:close/>
-                <a:lnTo>
-                  <a:pt x="1001864" y="278296"/>
-                </a:lnTo>
-                <a:close/>
-                <a:lnTo>
-                  <a:pt x="1006146" y="274014"/>
-                </a:lnTo>
-                <a:close/>
-                <a:lnTo>
-                  <a:pt x="1010427" y="269733"/>
-                </a:lnTo>
-                <a:close/>
-                <a:lnTo>
-                  <a:pt x="1014709" y="265451"/>
-                </a:lnTo>
-                <a:close/>
-                <a:lnTo>
-                  <a:pt x="1018990" y="261170"/>
-                </a:lnTo>
-                <a:close/>
-                <a:lnTo>
-                  <a:pt x="1023272" y="256888"/>
-                </a:lnTo>
-                <a:close/>
-                <a:lnTo>
-                  <a:pt x="1027553" y="252607"/>
-                </a:lnTo>
-                <a:close/>
-                <a:lnTo>
-                  <a:pt x="1031835" y="248325"/>
-                </a:lnTo>
-                <a:close/>
-                <a:lnTo>
-                  <a:pt x="1036116" y="244044"/>
-                </a:lnTo>
-                <a:close/>
-                <a:lnTo>
-                  <a:pt x="1040398" y="239762"/>
-                </a:lnTo>
-                <a:close/>
-                <a:lnTo>
-                  <a:pt x="1044679" y="235481"/>
-                </a:lnTo>
-                <a:close/>
-                <a:lnTo>
-                  <a:pt x="1048961" y="231199"/>
-                </a:lnTo>
-                <a:close/>
-                <a:lnTo>
-                  <a:pt x="1053242" y="226918"/>
-                </a:lnTo>
-                <a:close/>
-                <a:lnTo>
-                  <a:pt x="1057523" y="222637"/>
-                </a:lnTo>
-                <a:close/>
-                <a:lnTo>
-                  <a:pt x="1061805" y="218355"/>
-                </a:lnTo>
-                <a:close/>
-                <a:lnTo>
-                  <a:pt x="1066086" y="214074"/>
-                </a:lnTo>
-                <a:close/>
-                <a:lnTo>
-                  <a:pt x="1070368" y="209792"/>
-                </a:lnTo>
-                <a:close/>
-                <a:lnTo>
-                  <a:pt x="1074649" y="205511"/>
-                </a:lnTo>
-                <a:close/>
-                <a:lnTo>
-                  <a:pt x="1078931" y="201229"/>
-                </a:lnTo>
-                <a:close/>
-                <a:lnTo>
-                  <a:pt x="1083212" y="196948"/>
-                </a:lnTo>
-                <a:close/>
-                <a:lnTo>
-                  <a:pt x="1087494" y="192666"/>
-                </a:lnTo>
-                <a:close/>
-                <a:lnTo>
-                  <a:pt x="1091775" y="188385"/>
-                </a:lnTo>
-                <a:close/>
-                <a:lnTo>
-                  <a:pt x="1096057" y="184103"/>
-                </a:lnTo>
-                <a:close/>
-                <a:lnTo>
-                  <a:pt x="1100338" y="179822"/>
-                </a:lnTo>
-                <a:close/>
-                <a:lnTo>
-                  <a:pt x="1104620" y="175540"/>
-                </a:lnTo>
-                <a:close/>
-                <a:lnTo>
-                  <a:pt x="1108901" y="171259"/>
-                </a:lnTo>
-                <a:close/>
-                <a:lnTo>
-                  <a:pt x="1113183" y="166977"/>
-                </a:lnTo>
-                <a:close/>
-                <a:lnTo>
-                  <a:pt x="1117464" y="162696"/>
-                </a:lnTo>
-                <a:close/>
-                <a:lnTo>
-                  <a:pt x="1121746" y="158414"/>
-                </a:lnTo>
-                <a:close/>
-                <a:lnTo>
-                  <a:pt x="1126027" y="154133"/>
-                </a:lnTo>
-                <a:close/>
-                <a:lnTo>
-                  <a:pt x="1130308" y="149852"/>
-                </a:lnTo>
-                <a:close/>
-                <a:lnTo>
-                  <a:pt x="1134590" y="145570"/>
-                </a:lnTo>
-                <a:close/>
-                <a:lnTo>
-                  <a:pt x="1138871" y="141289"/>
-                </a:lnTo>
-                <a:close/>
-                <a:lnTo>
-                  <a:pt x="1143153" y="137007"/>
-                </a:lnTo>
-                <a:close/>
-                <a:lnTo>
-                  <a:pt x="1147434" y="132726"/>
-                </a:lnTo>
-                <a:close/>
-                <a:lnTo>
-                  <a:pt x="1151716" y="128444"/>
-                </a:lnTo>
-                <a:close/>
-                <a:lnTo>
-                  <a:pt x="1155997" y="124163"/>
-                </a:lnTo>
-                <a:close/>
-                <a:lnTo>
-                  <a:pt x="1160279" y="119881"/>
-                </a:lnTo>
-                <a:close/>
-                <a:lnTo>
-                  <a:pt x="1164560" y="115600"/>
-                </a:lnTo>
-                <a:close/>
-                <a:lnTo>
-                  <a:pt x="1168842" y="111318"/>
-                </a:lnTo>
-                <a:close/>
-                <a:lnTo>
-                  <a:pt x="1173123" y="107037"/>
-                </a:lnTo>
-                <a:close/>
-                <a:lnTo>
-                  <a:pt x="1177405" y="102755"/>
-                </a:lnTo>
-                <a:close/>
-                <a:lnTo>
-                  <a:pt x="1181686" y="98474"/>
-                </a:lnTo>
-                <a:close/>
-                <a:lnTo>
-                  <a:pt x="1185968" y="94192"/>
-                </a:lnTo>
-                <a:close/>
-                <a:lnTo>
-                  <a:pt x="1190249" y="89911"/>
-                </a:lnTo>
-                <a:close/>
-                <a:lnTo>
-                  <a:pt x="1194531" y="85629"/>
-                </a:lnTo>
-                <a:close/>
-                <a:lnTo>
-                  <a:pt x="1198812" y="81348"/>
-                </a:lnTo>
-                <a:close/>
-                <a:lnTo>
-                  <a:pt x="1203094" y="77066"/>
-                </a:lnTo>
-                <a:close/>
-                <a:lnTo>
-                  <a:pt x="1207375" y="72785"/>
-                </a:lnTo>
-                <a:close/>
-                <a:lnTo>
-                  <a:pt x="1211656" y="68504"/>
-                </a:lnTo>
-                <a:close/>
-                <a:lnTo>
-                  <a:pt x="1215938" y="64222"/>
-                </a:lnTo>
-                <a:close/>
-                <a:lnTo>
-                  <a:pt x="1220219" y="59941"/>
-                </a:lnTo>
-                <a:close/>
-                <a:lnTo>
-                  <a:pt x="1224501" y="55659"/>
-                </a:lnTo>
-                <a:close/>
-                <a:lnTo>
-                  <a:pt x="1228782" y="51378"/>
-                </a:lnTo>
-                <a:close/>
-                <a:lnTo>
-                  <a:pt x="1233064" y="47096"/>
-                </a:lnTo>
-                <a:close/>
-                <a:lnTo>
-                  <a:pt x="1237345" y="42815"/>
-                </a:lnTo>
-                <a:close/>
-                <a:lnTo>
-                  <a:pt x="1241627" y="38533"/>
-                </a:lnTo>
-                <a:close/>
-                <a:lnTo>
-                  <a:pt x="1245908" y="34252"/>
-                </a:lnTo>
-                <a:close/>
-                <a:lnTo>
-                  <a:pt x="1250190" y="29970"/>
-                </a:lnTo>
-                <a:close/>
-                <a:lnTo>
-                  <a:pt x="1254471" y="25689"/>
-                </a:lnTo>
-                <a:close/>
-                <a:lnTo>
-                  <a:pt x="1258753" y="21407"/>
-                </a:lnTo>
-                <a:close/>
-                <a:lnTo>
-                  <a:pt x="1263034" y="17126"/>
-                </a:lnTo>
-                <a:close/>
-                <a:lnTo>
-                  <a:pt x="1267316" y="12844"/>
-                </a:lnTo>
-                <a:close/>
-                <a:lnTo>
-                  <a:pt x="1271597" y="8563"/>
-                </a:lnTo>
-                <a:close/>
-                <a:lnTo>
-                  <a:pt x="1275879" y="4281"/>
-                </a:lnTo>
-                <a:close/>
-                <a:lnTo>
-                  <a:pt x="1280160" y="0"/>
+                  <a:pt x="582586" y="1039786"/>
+                </a:lnTo>
+                <a:close/>
+                <a:lnTo>
+                  <a:pt x="587173" y="1044373"/>
+                </a:lnTo>
+                <a:close/>
+                <a:lnTo>
+                  <a:pt x="591761" y="1048961"/>
+                </a:lnTo>
+                <a:close/>
+                <a:lnTo>
+                  <a:pt x="596348" y="1053548"/>
+                </a:lnTo>
+                <a:close/>
+                <a:lnTo>
+                  <a:pt x="600935" y="1058135"/>
+                </a:lnTo>
+                <a:close/>
+                <a:lnTo>
+                  <a:pt x="605522" y="1062722"/>
+                </a:lnTo>
+                <a:close/>
+                <a:lnTo>
+                  <a:pt x="610110" y="1067310"/>
+                </a:lnTo>
+                <a:close/>
+                <a:lnTo>
+                  <a:pt x="614697" y="1071897"/>
+                </a:lnTo>
+                <a:close/>
+                <a:lnTo>
+                  <a:pt x="619284" y="1076484"/>
+                </a:lnTo>
+                <a:close/>
+                <a:lnTo>
+                  <a:pt x="623872" y="1081072"/>
+                </a:lnTo>
+                <a:close/>
+                <a:lnTo>
+                  <a:pt x="628459" y="1085659"/>
+                </a:lnTo>
+                <a:close/>
+                <a:lnTo>
+                  <a:pt x="633046" y="1090246"/>
+                </a:lnTo>
+                <a:close/>
+                <a:lnTo>
+                  <a:pt x="637633" y="1094833"/>
+                </a:lnTo>
+                <a:close/>
+                <a:lnTo>
+                  <a:pt x="642221" y="1099421"/>
+                </a:lnTo>
+                <a:close/>
+                <a:lnTo>
+                  <a:pt x="646808" y="1104008"/>
+                </a:lnTo>
+                <a:close/>
+                <a:lnTo>
+                  <a:pt x="651395" y="1108595"/>
+                </a:lnTo>
+                <a:close/>
+                <a:lnTo>
+                  <a:pt x="655983" y="1113183"/>
+                </a:lnTo>
+                <a:close/>
+                <a:lnTo>
+                  <a:pt x="660570" y="1117770"/>
+                </a:lnTo>
+                <a:close/>
+                <a:lnTo>
+                  <a:pt x="665157" y="1122357"/>
+                </a:lnTo>
+                <a:close/>
+                <a:lnTo>
+                  <a:pt x="669744" y="1126947"/>
+                </a:lnTo>
+                <a:close/>
+                <a:lnTo>
+                  <a:pt x="674332" y="1131556"/>
+                </a:lnTo>
+                <a:close/>
+                <a:lnTo>
+                  <a:pt x="678919" y="1136324"/>
+                </a:lnTo>
+                <a:close/>
+                <a:lnTo>
+                  <a:pt x="683506" y="1141668"/>
+                </a:lnTo>
+                <a:close/>
+                <a:lnTo>
+                  <a:pt x="688094" y="683763"/>
+                </a:lnTo>
+                <a:close/>
+                <a:lnTo>
+                  <a:pt x="692681" y="678974"/>
+                </a:lnTo>
+                <a:close/>
+                <a:lnTo>
+                  <a:pt x="697268" y="674338"/>
+                </a:lnTo>
+                <a:close/>
+                <a:lnTo>
+                  <a:pt x="701856" y="669745"/>
+                </a:lnTo>
+                <a:close/>
+                <a:lnTo>
+                  <a:pt x="706443" y="665157"/>
+                </a:lnTo>
+                <a:close/>
+                <a:lnTo>
+                  <a:pt x="711030" y="660570"/>
+                </a:lnTo>
+                <a:close/>
+                <a:lnTo>
+                  <a:pt x="715617" y="655983"/>
+                </a:lnTo>
+                <a:close/>
+                <a:lnTo>
+                  <a:pt x="720205" y="651395"/>
+                </a:lnTo>
+                <a:close/>
+                <a:lnTo>
+                  <a:pt x="724792" y="646808"/>
+                </a:lnTo>
+                <a:close/>
+                <a:lnTo>
+                  <a:pt x="729379" y="642221"/>
+                </a:lnTo>
+                <a:close/>
+                <a:lnTo>
+                  <a:pt x="733967" y="637633"/>
+                </a:lnTo>
+                <a:close/>
+                <a:lnTo>
+                  <a:pt x="738554" y="633046"/>
+                </a:lnTo>
+                <a:close/>
+                <a:lnTo>
+                  <a:pt x="743141" y="628459"/>
+                </a:lnTo>
+                <a:close/>
+                <a:lnTo>
+                  <a:pt x="747728" y="623872"/>
+                </a:lnTo>
+                <a:close/>
+                <a:lnTo>
+                  <a:pt x="752316" y="619284"/>
+                </a:lnTo>
+                <a:close/>
+                <a:lnTo>
+                  <a:pt x="756903" y="614697"/>
+                </a:lnTo>
+                <a:close/>
+                <a:lnTo>
+                  <a:pt x="761490" y="610110"/>
+                </a:lnTo>
+                <a:close/>
+                <a:lnTo>
+                  <a:pt x="766078" y="605522"/>
+                </a:lnTo>
+                <a:close/>
+                <a:lnTo>
+                  <a:pt x="770665" y="600935"/>
+                </a:lnTo>
+                <a:close/>
+                <a:lnTo>
+                  <a:pt x="775252" y="596348"/>
+                </a:lnTo>
+                <a:close/>
+                <a:lnTo>
+                  <a:pt x="779839" y="591761"/>
+                </a:lnTo>
+                <a:close/>
+                <a:lnTo>
+                  <a:pt x="784427" y="587173"/>
+                </a:lnTo>
+                <a:close/>
+                <a:lnTo>
+                  <a:pt x="789014" y="582586"/>
+                </a:lnTo>
+                <a:close/>
+                <a:lnTo>
+                  <a:pt x="793601" y="577999"/>
+                </a:lnTo>
+                <a:close/>
+                <a:lnTo>
+                  <a:pt x="798189" y="573411"/>
+                </a:lnTo>
+                <a:close/>
+                <a:lnTo>
+                  <a:pt x="802776" y="568824"/>
+                </a:lnTo>
+                <a:close/>
+                <a:lnTo>
+                  <a:pt x="807363" y="564237"/>
+                </a:lnTo>
+                <a:close/>
+                <a:lnTo>
+                  <a:pt x="811951" y="559649"/>
+                </a:lnTo>
+                <a:close/>
+                <a:lnTo>
+                  <a:pt x="816538" y="555062"/>
+                </a:lnTo>
+                <a:close/>
+                <a:lnTo>
+                  <a:pt x="821125" y="550475"/>
+                </a:lnTo>
+                <a:close/>
+                <a:lnTo>
+                  <a:pt x="825712" y="545888"/>
+                </a:lnTo>
+                <a:close/>
+                <a:lnTo>
+                  <a:pt x="830300" y="541300"/>
+                </a:lnTo>
+                <a:close/>
+                <a:lnTo>
+                  <a:pt x="834887" y="536713"/>
+                </a:lnTo>
+                <a:close/>
+                <a:lnTo>
+                  <a:pt x="839474" y="532126"/>
+                </a:lnTo>
+                <a:close/>
+                <a:lnTo>
+                  <a:pt x="844062" y="527538"/>
+                </a:lnTo>
+                <a:close/>
+                <a:lnTo>
+                  <a:pt x="848649" y="522951"/>
+                </a:lnTo>
+                <a:close/>
+                <a:lnTo>
+                  <a:pt x="853236" y="518364"/>
+                </a:lnTo>
+                <a:close/>
+                <a:lnTo>
+                  <a:pt x="857823" y="513777"/>
+                </a:lnTo>
+                <a:close/>
+                <a:lnTo>
+                  <a:pt x="862411" y="509189"/>
+                </a:lnTo>
+                <a:close/>
+                <a:lnTo>
+                  <a:pt x="866998" y="504602"/>
+                </a:lnTo>
+                <a:close/>
+                <a:lnTo>
+                  <a:pt x="871585" y="500015"/>
+                </a:lnTo>
+                <a:close/>
+                <a:lnTo>
+                  <a:pt x="876173" y="495427"/>
+                </a:lnTo>
+                <a:close/>
+                <a:lnTo>
+                  <a:pt x="880760" y="490840"/>
+                </a:lnTo>
+                <a:close/>
+                <a:lnTo>
+                  <a:pt x="885347" y="486253"/>
+                </a:lnTo>
+                <a:close/>
+                <a:lnTo>
+                  <a:pt x="889934" y="481666"/>
+                </a:lnTo>
+                <a:close/>
+                <a:lnTo>
+                  <a:pt x="894522" y="477078"/>
+                </a:lnTo>
+                <a:close/>
+                <a:lnTo>
+                  <a:pt x="899109" y="472491"/>
+                </a:lnTo>
+                <a:close/>
+                <a:lnTo>
+                  <a:pt x="903696" y="467904"/>
+                </a:lnTo>
+                <a:close/>
+                <a:lnTo>
+                  <a:pt x="908284" y="463316"/>
+                </a:lnTo>
+                <a:close/>
+                <a:lnTo>
+                  <a:pt x="912871" y="458729"/>
+                </a:lnTo>
+                <a:close/>
+                <a:lnTo>
+                  <a:pt x="917458" y="454142"/>
+                </a:lnTo>
+                <a:close/>
+                <a:lnTo>
+                  <a:pt x="922045" y="449555"/>
+                </a:lnTo>
+                <a:close/>
+                <a:lnTo>
+                  <a:pt x="926633" y="444967"/>
+                </a:lnTo>
+                <a:close/>
+                <a:lnTo>
+                  <a:pt x="931220" y="440380"/>
+                </a:lnTo>
+                <a:close/>
+                <a:lnTo>
+                  <a:pt x="935807" y="435793"/>
+                </a:lnTo>
+                <a:close/>
+                <a:lnTo>
+                  <a:pt x="940395" y="431205"/>
+                </a:lnTo>
+                <a:close/>
+                <a:lnTo>
+                  <a:pt x="944982" y="426618"/>
+                </a:lnTo>
+                <a:close/>
+                <a:lnTo>
+                  <a:pt x="949569" y="422031"/>
+                </a:lnTo>
+                <a:close/>
+                <a:lnTo>
+                  <a:pt x="954157" y="417443"/>
+                </a:lnTo>
+                <a:close/>
+                <a:lnTo>
+                  <a:pt x="958744" y="412856"/>
+                </a:lnTo>
+                <a:close/>
+                <a:lnTo>
+                  <a:pt x="963331" y="408269"/>
+                </a:lnTo>
+                <a:close/>
+                <a:lnTo>
+                  <a:pt x="967918" y="403682"/>
+                </a:lnTo>
+                <a:close/>
+                <a:lnTo>
+                  <a:pt x="972506" y="399094"/>
+                </a:lnTo>
+                <a:close/>
+                <a:lnTo>
+                  <a:pt x="977093" y="394507"/>
+                </a:lnTo>
+                <a:close/>
+                <a:lnTo>
+                  <a:pt x="981680" y="389920"/>
+                </a:lnTo>
+                <a:close/>
+                <a:lnTo>
+                  <a:pt x="986268" y="385332"/>
+                </a:lnTo>
+                <a:close/>
+                <a:lnTo>
+                  <a:pt x="990855" y="380745"/>
+                </a:lnTo>
+                <a:close/>
+                <a:lnTo>
+                  <a:pt x="995442" y="376158"/>
+                </a:lnTo>
+                <a:close/>
+                <a:lnTo>
+                  <a:pt x="1000029" y="371571"/>
+                </a:lnTo>
+                <a:close/>
+                <a:lnTo>
+                  <a:pt x="1004617" y="366983"/>
+                </a:lnTo>
+                <a:close/>
+                <a:lnTo>
+                  <a:pt x="1009204" y="362396"/>
+                </a:lnTo>
+                <a:close/>
+                <a:lnTo>
+                  <a:pt x="1013791" y="357809"/>
+                </a:lnTo>
+                <a:close/>
+                <a:lnTo>
+                  <a:pt x="1018379" y="353221"/>
+                </a:lnTo>
+                <a:close/>
+                <a:lnTo>
+                  <a:pt x="1022966" y="348634"/>
+                </a:lnTo>
+                <a:close/>
+                <a:lnTo>
+                  <a:pt x="1027553" y="344047"/>
+                </a:lnTo>
+                <a:close/>
+                <a:lnTo>
+                  <a:pt x="1032140" y="339460"/>
+                </a:lnTo>
+                <a:close/>
+                <a:lnTo>
+                  <a:pt x="1036728" y="334872"/>
+                </a:lnTo>
+                <a:close/>
+                <a:lnTo>
+                  <a:pt x="1041315" y="330285"/>
+                </a:lnTo>
+                <a:close/>
+                <a:lnTo>
+                  <a:pt x="1045902" y="325698"/>
+                </a:lnTo>
+                <a:close/>
+                <a:lnTo>
+                  <a:pt x="1050490" y="321110"/>
+                </a:lnTo>
+                <a:close/>
+                <a:lnTo>
+                  <a:pt x="1055077" y="316523"/>
+                </a:lnTo>
+                <a:close/>
+                <a:lnTo>
+                  <a:pt x="1059664" y="311936"/>
+                </a:lnTo>
+                <a:close/>
+                <a:lnTo>
+                  <a:pt x="1064252" y="307348"/>
+                </a:lnTo>
+                <a:close/>
+                <a:lnTo>
+                  <a:pt x="1068839" y="302761"/>
+                </a:lnTo>
+                <a:close/>
+                <a:lnTo>
+                  <a:pt x="1073426" y="298174"/>
+                </a:lnTo>
+                <a:close/>
+                <a:lnTo>
+                  <a:pt x="1078013" y="293587"/>
+                </a:lnTo>
+                <a:close/>
+                <a:lnTo>
+                  <a:pt x="1082601" y="288999"/>
+                </a:lnTo>
+                <a:close/>
+                <a:lnTo>
+                  <a:pt x="1087188" y="284412"/>
+                </a:lnTo>
+                <a:close/>
+                <a:lnTo>
+                  <a:pt x="1091775" y="279825"/>
+                </a:lnTo>
+                <a:close/>
+                <a:lnTo>
+                  <a:pt x="1096363" y="275237"/>
+                </a:lnTo>
+                <a:close/>
+                <a:lnTo>
+                  <a:pt x="1100950" y="270650"/>
+                </a:lnTo>
+                <a:close/>
+                <a:lnTo>
+                  <a:pt x="1105537" y="266063"/>
+                </a:lnTo>
+                <a:close/>
+                <a:lnTo>
+                  <a:pt x="1110124" y="261476"/>
+                </a:lnTo>
+                <a:close/>
+                <a:lnTo>
+                  <a:pt x="1114712" y="256888"/>
+                </a:lnTo>
+                <a:close/>
+                <a:lnTo>
+                  <a:pt x="1119299" y="252301"/>
+                </a:lnTo>
+                <a:close/>
+                <a:lnTo>
+                  <a:pt x="1123886" y="247714"/>
+                </a:lnTo>
+                <a:close/>
+                <a:lnTo>
+                  <a:pt x="1128474" y="243126"/>
+                </a:lnTo>
+                <a:close/>
+                <a:lnTo>
+                  <a:pt x="1133061" y="238539"/>
+                </a:lnTo>
+                <a:close/>
+                <a:lnTo>
+                  <a:pt x="1137648" y="233952"/>
+                </a:lnTo>
+                <a:close/>
+                <a:lnTo>
+                  <a:pt x="1142235" y="229365"/>
+                </a:lnTo>
+                <a:close/>
+                <a:lnTo>
+                  <a:pt x="1146823" y="224777"/>
+                </a:lnTo>
+                <a:close/>
+                <a:lnTo>
+                  <a:pt x="1151410" y="220190"/>
+                </a:lnTo>
+                <a:close/>
+                <a:lnTo>
+                  <a:pt x="1155997" y="215603"/>
+                </a:lnTo>
+                <a:close/>
+                <a:lnTo>
+                  <a:pt x="1160585" y="211015"/>
+                </a:lnTo>
+                <a:close/>
+                <a:lnTo>
+                  <a:pt x="1165172" y="206428"/>
+                </a:lnTo>
+                <a:close/>
+                <a:lnTo>
+                  <a:pt x="1169759" y="201841"/>
+                </a:lnTo>
+                <a:close/>
+                <a:lnTo>
+                  <a:pt x="1174346" y="197254"/>
+                </a:lnTo>
+                <a:close/>
+                <a:lnTo>
+                  <a:pt x="1178934" y="192666"/>
+                </a:lnTo>
+                <a:close/>
+                <a:lnTo>
+                  <a:pt x="1183521" y="188079"/>
+                </a:lnTo>
+                <a:close/>
+                <a:lnTo>
+                  <a:pt x="1188108" y="183492"/>
+                </a:lnTo>
+                <a:close/>
+                <a:lnTo>
+                  <a:pt x="1192696" y="178904"/>
+                </a:lnTo>
+                <a:close/>
+                <a:lnTo>
+                  <a:pt x="1197283" y="174317"/>
+                </a:lnTo>
+                <a:close/>
+                <a:lnTo>
+                  <a:pt x="1201870" y="169730"/>
+                </a:lnTo>
+                <a:close/>
+                <a:lnTo>
+                  <a:pt x="1206458" y="165142"/>
+                </a:lnTo>
+                <a:close/>
+                <a:lnTo>
+                  <a:pt x="1211045" y="160555"/>
+                </a:lnTo>
+                <a:close/>
+                <a:lnTo>
+                  <a:pt x="1215632" y="155968"/>
+                </a:lnTo>
+                <a:close/>
+                <a:lnTo>
+                  <a:pt x="1220219" y="151381"/>
+                </a:lnTo>
+                <a:close/>
+                <a:lnTo>
+                  <a:pt x="1224807" y="146793"/>
+                </a:lnTo>
+                <a:close/>
+                <a:lnTo>
+                  <a:pt x="1229394" y="142206"/>
+                </a:lnTo>
+                <a:close/>
+                <a:lnTo>
+                  <a:pt x="1233981" y="137619"/>
+                </a:lnTo>
+                <a:close/>
+                <a:lnTo>
+                  <a:pt x="1238569" y="133031"/>
+                </a:lnTo>
+                <a:close/>
+                <a:lnTo>
+                  <a:pt x="1243156" y="128444"/>
+                </a:lnTo>
+                <a:close/>
+                <a:lnTo>
+                  <a:pt x="1247743" y="123857"/>
+                </a:lnTo>
+                <a:close/>
+                <a:lnTo>
+                  <a:pt x="1252330" y="119270"/>
+                </a:lnTo>
+                <a:close/>
+                <a:lnTo>
+                  <a:pt x="1256918" y="114682"/>
+                </a:lnTo>
+                <a:close/>
+                <a:lnTo>
+                  <a:pt x="1261505" y="110095"/>
+                </a:lnTo>
+                <a:close/>
+                <a:lnTo>
+                  <a:pt x="1266092" y="105508"/>
+                </a:lnTo>
+                <a:close/>
+                <a:lnTo>
+                  <a:pt x="1270680" y="100920"/>
+                </a:lnTo>
+                <a:close/>
+                <a:lnTo>
+                  <a:pt x="1275267" y="96333"/>
+                </a:lnTo>
+                <a:close/>
+                <a:lnTo>
+                  <a:pt x="1279854" y="91746"/>
+                </a:lnTo>
+                <a:close/>
+                <a:lnTo>
+                  <a:pt x="1284441" y="87159"/>
+                </a:lnTo>
+                <a:close/>
+                <a:lnTo>
+                  <a:pt x="1289029" y="82571"/>
+                </a:lnTo>
+                <a:close/>
+                <a:lnTo>
+                  <a:pt x="1293616" y="77984"/>
+                </a:lnTo>
+                <a:close/>
+                <a:lnTo>
+                  <a:pt x="1298203" y="73397"/>
+                </a:lnTo>
+                <a:close/>
+                <a:lnTo>
+                  <a:pt x="1302791" y="68809"/>
+                </a:lnTo>
+                <a:close/>
+                <a:lnTo>
+                  <a:pt x="1307378" y="64222"/>
+                </a:lnTo>
+                <a:close/>
+                <a:lnTo>
+                  <a:pt x="1311965" y="59635"/>
+                </a:lnTo>
+                <a:close/>
+                <a:lnTo>
+                  <a:pt x="1316553" y="55047"/>
+                </a:lnTo>
+                <a:close/>
+                <a:lnTo>
+                  <a:pt x="1321140" y="50460"/>
+                </a:lnTo>
+                <a:close/>
+                <a:lnTo>
+                  <a:pt x="1325727" y="45873"/>
+                </a:lnTo>
+                <a:close/>
+                <a:lnTo>
+                  <a:pt x="1330314" y="41286"/>
+                </a:lnTo>
+                <a:close/>
+                <a:lnTo>
+                  <a:pt x="1334902" y="36698"/>
+                </a:lnTo>
+                <a:close/>
+                <a:lnTo>
+                  <a:pt x="1339489" y="32111"/>
+                </a:lnTo>
+                <a:close/>
+                <a:lnTo>
+                  <a:pt x="1344076" y="27524"/>
+                </a:lnTo>
+                <a:close/>
+                <a:lnTo>
+                  <a:pt x="1348664" y="22936"/>
+                </a:lnTo>
+                <a:close/>
+                <a:lnTo>
+                  <a:pt x="1353251" y="18349"/>
+                </a:lnTo>
+                <a:close/>
+                <a:lnTo>
+                  <a:pt x="1357838" y="13762"/>
+                </a:lnTo>
+                <a:close/>
+                <a:lnTo>
+                  <a:pt x="1362425" y="9175"/>
+                </a:lnTo>
+                <a:close/>
+                <a:lnTo>
+                  <a:pt x="1367013" y="4587"/>
+                </a:lnTo>
+                <a:close/>
+                <a:lnTo>
+                  <a:pt x="1371600" y="0"/>
                 </a:lnTo>
                 <a:close/>
               </a:path>
@@ -4389,7 +4389,7 @@
           </a:custGeom>
           <a:ln w="31750">
             <a:solidFill>
-              <a:srgbClr val="00E5FF"/>
+              <a:srgbClr val="FFFFFF"/>
             </a:solidFill>
           </a:ln>
         </p:spPr>
@@ -4538,7 +4538,7 @@
             <a:avLst/>
           </a:prstGeom>
           <a:solidFill>
-            <a:srgbClr val="0A0A0A"/>
+            <a:srgbClr val="000000"/>
           </a:solidFill>
           <a:ln w="12700">
             <a:solidFill>
@@ -4621,8 +4621,8 @@
         </p:nvSpPr>
         <p:spPr>
           <a:xfrm>
-            <a:off x="4846320" y="1931670"/>
-            <a:ext cx="91440" cy="91440"/>
+            <a:off x="4800600" y="1885950"/>
+            <a:ext cx="137160" cy="137160"/>
           </a:xfrm>
           <a:custGeom>
             <a:avLst/>
@@ -4631,16 +4631,12 @@
             <a:cxnLst/>
             <a:rect l="l" t="t" r="r" b="b"/>
             <a:pathLst>
-              <a:path w="91440" h="91440">
+              <a:path w="137160" h="137160">
                 <a:moveTo>
                   <a:pt x="0" y="0"/>
                 </a:moveTo>
                 <a:lnTo>
-                  <a:pt x="924" y="924"/>
-                </a:lnTo>
-                <a:close/>
-                <a:lnTo>
-                  <a:pt x="1847" y="1847"/>
+                  <a:pt x="1385" y="1385"/>
                 </a:lnTo>
                 <a:close/>
                 <a:lnTo>
@@ -4648,11 +4644,7 @@
                 </a:lnTo>
                 <a:close/>
                 <a:lnTo>
-                  <a:pt x="3695" y="3695"/>
-                </a:lnTo>
-                <a:close/>
-                <a:lnTo>
-                  <a:pt x="4618" y="4618"/>
+                  <a:pt x="4156" y="4156"/>
                 </a:lnTo>
                 <a:close/>
                 <a:lnTo>
@@ -4660,11 +4652,7 @@
                 </a:lnTo>
                 <a:close/>
                 <a:lnTo>
-                  <a:pt x="6465" y="6465"/>
-                </a:lnTo>
-                <a:close/>
-                <a:lnTo>
-                  <a:pt x="7389" y="7389"/>
+                  <a:pt x="6927" y="6927"/>
                 </a:lnTo>
                 <a:close/>
                 <a:lnTo>
@@ -4672,11 +4660,7 @@
                 </a:lnTo>
                 <a:close/>
                 <a:lnTo>
-                  <a:pt x="9236" y="9236"/>
-                </a:lnTo>
-                <a:close/>
-                <a:lnTo>
-                  <a:pt x="10160" y="10160"/>
+                  <a:pt x="9698" y="9698"/>
                 </a:lnTo>
                 <a:close/>
                 <a:lnTo>
@@ -4684,11 +4668,7 @@
                 </a:lnTo>
                 <a:close/>
                 <a:lnTo>
-                  <a:pt x="12007" y="12007"/>
-                </a:lnTo>
-                <a:close/>
-                <a:lnTo>
-                  <a:pt x="12931" y="12931"/>
+                  <a:pt x="12469" y="12469"/>
                 </a:lnTo>
                 <a:close/>
                 <a:lnTo>
@@ -4696,11 +4676,7 @@
                 </a:lnTo>
                 <a:close/>
                 <a:lnTo>
-                  <a:pt x="14778" y="14778"/>
-                </a:lnTo>
-                <a:close/>
-                <a:lnTo>
-                  <a:pt x="15702" y="15702"/>
+                  <a:pt x="15240" y="15240"/>
                 </a:lnTo>
                 <a:close/>
                 <a:lnTo>
@@ -4708,11 +4684,7 @@
                 </a:lnTo>
                 <a:close/>
                 <a:lnTo>
-                  <a:pt x="17549" y="17549"/>
-                </a:lnTo>
-                <a:close/>
-                <a:lnTo>
-                  <a:pt x="18473" y="18473"/>
+                  <a:pt x="18011" y="18011"/>
                 </a:lnTo>
                 <a:close/>
                 <a:lnTo>
@@ -4720,11 +4692,7 @@
                 </a:lnTo>
                 <a:close/>
                 <a:lnTo>
-                  <a:pt x="20320" y="20320"/>
-                </a:lnTo>
-                <a:close/>
-                <a:lnTo>
-                  <a:pt x="21244" y="21244"/>
+                  <a:pt x="20782" y="20782"/>
                 </a:lnTo>
                 <a:close/>
                 <a:lnTo>
@@ -4732,11 +4700,7 @@
                 </a:lnTo>
                 <a:close/>
                 <a:lnTo>
-                  <a:pt x="23091" y="23091"/>
-                </a:lnTo>
-                <a:close/>
-                <a:lnTo>
-                  <a:pt x="24015" y="24015"/>
+                  <a:pt x="23553" y="23553"/>
                 </a:lnTo>
                 <a:close/>
                 <a:lnTo>
@@ -4744,11 +4708,7 @@
                 </a:lnTo>
                 <a:close/>
                 <a:lnTo>
-                  <a:pt x="25862" y="25862"/>
-                </a:lnTo>
-                <a:close/>
-                <a:lnTo>
-                  <a:pt x="26785" y="26785"/>
+                  <a:pt x="26324" y="26324"/>
                 </a:lnTo>
                 <a:close/>
                 <a:lnTo>
@@ -4756,11 +4716,7 @@
                 </a:lnTo>
                 <a:close/>
                 <a:lnTo>
-                  <a:pt x="28633" y="28633"/>
-                </a:lnTo>
-                <a:close/>
-                <a:lnTo>
-                  <a:pt x="29556" y="29556"/>
+                  <a:pt x="29095" y="29095"/>
                 </a:lnTo>
                 <a:close/>
                 <a:lnTo>
@@ -4768,11 +4724,7 @@
                 </a:lnTo>
                 <a:close/>
                 <a:lnTo>
-                  <a:pt x="31404" y="31404"/>
-                </a:lnTo>
-                <a:close/>
-                <a:lnTo>
-                  <a:pt x="32327" y="32327"/>
+                  <a:pt x="31865" y="31865"/>
                 </a:lnTo>
                 <a:close/>
                 <a:lnTo>
@@ -4780,11 +4732,7 @@
                 </a:lnTo>
                 <a:close/>
                 <a:lnTo>
-                  <a:pt x="34175" y="34175"/>
-                </a:lnTo>
-                <a:close/>
-                <a:lnTo>
-                  <a:pt x="35098" y="35098"/>
+                  <a:pt x="34636" y="34636"/>
                 </a:lnTo>
                 <a:close/>
                 <a:lnTo>
@@ -4792,11 +4740,7 @@
                 </a:lnTo>
                 <a:close/>
                 <a:lnTo>
-                  <a:pt x="36945" y="36945"/>
-                </a:lnTo>
-                <a:close/>
-                <a:lnTo>
-                  <a:pt x="37869" y="37869"/>
+                  <a:pt x="37407" y="37407"/>
                 </a:lnTo>
                 <a:close/>
                 <a:lnTo>
@@ -4804,11 +4748,7 @@
                 </a:lnTo>
                 <a:close/>
                 <a:lnTo>
-                  <a:pt x="39716" y="39716"/>
-                </a:lnTo>
-                <a:close/>
-                <a:lnTo>
-                  <a:pt x="40640" y="40640"/>
+                  <a:pt x="40178" y="40178"/>
                 </a:lnTo>
                 <a:close/>
                 <a:lnTo>
@@ -4816,11 +4756,7 @@
                 </a:lnTo>
                 <a:close/>
                 <a:lnTo>
-                  <a:pt x="42487" y="42487"/>
-                </a:lnTo>
-                <a:close/>
-                <a:lnTo>
-                  <a:pt x="43411" y="43411"/>
+                  <a:pt x="42949" y="42949"/>
                 </a:lnTo>
                 <a:close/>
                 <a:lnTo>
@@ -4828,11 +4764,7 @@
                 </a:lnTo>
                 <a:close/>
                 <a:lnTo>
-                  <a:pt x="45258" y="45258"/>
-                </a:lnTo>
-                <a:close/>
-                <a:lnTo>
-                  <a:pt x="46182" y="46182"/>
+                  <a:pt x="45720" y="45720"/>
                 </a:lnTo>
                 <a:close/>
                 <a:lnTo>
@@ -4840,11 +4772,7 @@
                 </a:lnTo>
                 <a:close/>
                 <a:lnTo>
-                  <a:pt x="48029" y="48029"/>
-                </a:lnTo>
-                <a:close/>
-                <a:lnTo>
-                  <a:pt x="48953" y="48953"/>
+                  <a:pt x="48491" y="48491"/>
                 </a:lnTo>
                 <a:close/>
                 <a:lnTo>
@@ -4852,11 +4780,7 @@
                 </a:lnTo>
                 <a:close/>
                 <a:lnTo>
-                  <a:pt x="50800" y="50800"/>
-                </a:lnTo>
-                <a:close/>
-                <a:lnTo>
-                  <a:pt x="51724" y="51724"/>
+                  <a:pt x="51262" y="51262"/>
                 </a:lnTo>
                 <a:close/>
                 <a:lnTo>
@@ -4864,11 +4788,7 @@
                 </a:lnTo>
                 <a:close/>
                 <a:lnTo>
-                  <a:pt x="53571" y="53571"/>
-                </a:lnTo>
-                <a:close/>
-                <a:lnTo>
-                  <a:pt x="54495" y="54495"/>
+                  <a:pt x="54033" y="54033"/>
                 </a:lnTo>
                 <a:close/>
                 <a:lnTo>
@@ -4876,11 +4796,7 @@
                 </a:lnTo>
                 <a:close/>
                 <a:lnTo>
-                  <a:pt x="56342" y="56342"/>
-                </a:lnTo>
-                <a:close/>
-                <a:lnTo>
-                  <a:pt x="57265" y="57265"/>
+                  <a:pt x="56804" y="56804"/>
                 </a:lnTo>
                 <a:close/>
                 <a:lnTo>
@@ -4888,11 +4804,7 @@
                 </a:lnTo>
                 <a:close/>
                 <a:lnTo>
-                  <a:pt x="59113" y="59113"/>
-                </a:lnTo>
-                <a:close/>
-                <a:lnTo>
-                  <a:pt x="60036" y="60036"/>
+                  <a:pt x="59575" y="59575"/>
                 </a:lnTo>
                 <a:close/>
                 <a:lnTo>
@@ -4900,11 +4812,7 @@
                 </a:lnTo>
                 <a:close/>
                 <a:lnTo>
-                  <a:pt x="61884" y="61884"/>
-                </a:lnTo>
-                <a:close/>
-                <a:lnTo>
-                  <a:pt x="62807" y="62807"/>
+                  <a:pt x="62345" y="62345"/>
                 </a:lnTo>
                 <a:close/>
                 <a:lnTo>
@@ -4912,11 +4820,7 @@
                 </a:lnTo>
                 <a:close/>
                 <a:lnTo>
-                  <a:pt x="64655" y="64655"/>
-                </a:lnTo>
-                <a:close/>
-                <a:lnTo>
-                  <a:pt x="65578" y="65578"/>
+                  <a:pt x="65116" y="65116"/>
                 </a:lnTo>
                 <a:close/>
                 <a:lnTo>
@@ -4924,11 +4828,7 @@
                 </a:lnTo>
                 <a:close/>
                 <a:lnTo>
-                  <a:pt x="67425" y="67425"/>
-                </a:lnTo>
-                <a:close/>
-                <a:lnTo>
-                  <a:pt x="68349" y="68349"/>
+                  <a:pt x="67887" y="67887"/>
                 </a:lnTo>
                 <a:close/>
                 <a:lnTo>
@@ -4936,11 +4836,7 @@
                 </a:lnTo>
                 <a:close/>
                 <a:lnTo>
-                  <a:pt x="70196" y="70196"/>
-                </a:lnTo>
-                <a:close/>
-                <a:lnTo>
-                  <a:pt x="71120" y="71120"/>
+                  <a:pt x="70658" y="70658"/>
                 </a:lnTo>
                 <a:close/>
                 <a:lnTo>
@@ -4948,11 +4844,7 @@
                 </a:lnTo>
                 <a:close/>
                 <a:lnTo>
-                  <a:pt x="72967" y="72967"/>
-                </a:lnTo>
-                <a:close/>
-                <a:lnTo>
-                  <a:pt x="73891" y="73891"/>
+                  <a:pt x="73429" y="73429"/>
                 </a:lnTo>
                 <a:close/>
                 <a:lnTo>
@@ -4960,11 +4852,7 @@
                 </a:lnTo>
                 <a:close/>
                 <a:lnTo>
-                  <a:pt x="75738" y="75738"/>
-                </a:lnTo>
-                <a:close/>
-                <a:lnTo>
-                  <a:pt x="76662" y="76662"/>
+                  <a:pt x="76200" y="76200"/>
                 </a:lnTo>
                 <a:close/>
                 <a:lnTo>
@@ -4972,11 +4860,7 @@
                 </a:lnTo>
                 <a:close/>
                 <a:lnTo>
-                  <a:pt x="78509" y="78509"/>
-                </a:lnTo>
-                <a:close/>
-                <a:lnTo>
-                  <a:pt x="79433" y="79433"/>
+                  <a:pt x="78971" y="78971"/>
                 </a:lnTo>
                 <a:close/>
                 <a:lnTo>
@@ -4984,11 +4868,7 @@
                 </a:lnTo>
                 <a:close/>
                 <a:lnTo>
-                  <a:pt x="81280" y="81280"/>
-                </a:lnTo>
-                <a:close/>
-                <a:lnTo>
-                  <a:pt x="82204" y="82204"/>
+                  <a:pt x="81742" y="81742"/>
                 </a:lnTo>
                 <a:close/>
                 <a:lnTo>
@@ -4996,11 +4876,7 @@
                 </a:lnTo>
                 <a:close/>
                 <a:lnTo>
-                  <a:pt x="84051" y="84051"/>
-                </a:lnTo>
-                <a:close/>
-                <a:lnTo>
-                  <a:pt x="84975" y="84975"/>
+                  <a:pt x="84513" y="84513"/>
                 </a:lnTo>
                 <a:close/>
                 <a:lnTo>
@@ -5008,11 +4884,7 @@
                 </a:lnTo>
                 <a:close/>
                 <a:lnTo>
-                  <a:pt x="86822" y="86822"/>
-                </a:lnTo>
-                <a:close/>
-                <a:lnTo>
-                  <a:pt x="87745" y="87745"/>
+                  <a:pt x="87284" y="87284"/>
                 </a:lnTo>
                 <a:close/>
                 <a:lnTo>
@@ -5020,15 +4892,143 @@
                 </a:lnTo>
                 <a:close/>
                 <a:lnTo>
-                  <a:pt x="89593" y="89593"/>
-                </a:lnTo>
-                <a:close/>
-                <a:lnTo>
-                  <a:pt x="90516" y="90516"/>
+                  <a:pt x="90055" y="90055"/>
                 </a:lnTo>
                 <a:close/>
                 <a:lnTo>
                   <a:pt x="91440" y="91440"/>
+                </a:lnTo>
+                <a:close/>
+                <a:lnTo>
+                  <a:pt x="92825" y="92825"/>
+                </a:lnTo>
+                <a:close/>
+                <a:lnTo>
+                  <a:pt x="94211" y="94211"/>
+                </a:lnTo>
+                <a:close/>
+                <a:lnTo>
+                  <a:pt x="95596" y="95596"/>
+                </a:lnTo>
+                <a:close/>
+                <a:lnTo>
+                  <a:pt x="96982" y="96982"/>
+                </a:lnTo>
+                <a:close/>
+                <a:lnTo>
+                  <a:pt x="98367" y="98367"/>
+                </a:lnTo>
+                <a:close/>
+                <a:lnTo>
+                  <a:pt x="99753" y="99753"/>
+                </a:lnTo>
+                <a:close/>
+                <a:lnTo>
+                  <a:pt x="101138" y="101138"/>
+                </a:lnTo>
+                <a:close/>
+                <a:lnTo>
+                  <a:pt x="102524" y="102524"/>
+                </a:lnTo>
+                <a:close/>
+                <a:lnTo>
+                  <a:pt x="103909" y="103909"/>
+                </a:lnTo>
+                <a:close/>
+                <a:lnTo>
+                  <a:pt x="105295" y="105295"/>
+                </a:lnTo>
+                <a:close/>
+                <a:lnTo>
+                  <a:pt x="106680" y="106680"/>
+                </a:lnTo>
+                <a:close/>
+                <a:lnTo>
+                  <a:pt x="108065" y="108065"/>
+                </a:lnTo>
+                <a:close/>
+                <a:lnTo>
+                  <a:pt x="109451" y="109451"/>
+                </a:lnTo>
+                <a:close/>
+                <a:lnTo>
+                  <a:pt x="110836" y="110836"/>
+                </a:lnTo>
+                <a:close/>
+                <a:lnTo>
+                  <a:pt x="112222" y="112222"/>
+                </a:lnTo>
+                <a:close/>
+                <a:lnTo>
+                  <a:pt x="113607" y="113607"/>
+                </a:lnTo>
+                <a:close/>
+                <a:lnTo>
+                  <a:pt x="114993" y="114993"/>
+                </a:lnTo>
+                <a:close/>
+                <a:lnTo>
+                  <a:pt x="116378" y="116378"/>
+                </a:lnTo>
+                <a:close/>
+                <a:lnTo>
+                  <a:pt x="117764" y="117764"/>
+                </a:lnTo>
+                <a:close/>
+                <a:lnTo>
+                  <a:pt x="119149" y="119149"/>
+                </a:lnTo>
+                <a:close/>
+                <a:lnTo>
+                  <a:pt x="120535" y="120535"/>
+                </a:lnTo>
+                <a:close/>
+                <a:lnTo>
+                  <a:pt x="121920" y="121920"/>
+                </a:lnTo>
+                <a:close/>
+                <a:lnTo>
+                  <a:pt x="123305" y="123305"/>
+                </a:lnTo>
+                <a:close/>
+                <a:lnTo>
+                  <a:pt x="124691" y="124691"/>
+                </a:lnTo>
+                <a:close/>
+                <a:lnTo>
+                  <a:pt x="126076" y="126076"/>
+                </a:lnTo>
+                <a:close/>
+                <a:lnTo>
+                  <a:pt x="127462" y="127462"/>
+                </a:lnTo>
+                <a:close/>
+                <a:lnTo>
+                  <a:pt x="128847" y="128847"/>
+                </a:lnTo>
+                <a:close/>
+                <a:lnTo>
+                  <a:pt x="130233" y="130233"/>
+                </a:lnTo>
+                <a:close/>
+                <a:lnTo>
+                  <a:pt x="131618" y="131618"/>
+                </a:lnTo>
+                <a:close/>
+                <a:lnTo>
+                  <a:pt x="133004" y="133004"/>
+                </a:lnTo>
+                <a:close/>
+                <a:lnTo>
+                  <a:pt x="134389" y="134389"/>
+                </a:lnTo>
+                <a:close/>
+                <a:lnTo>
+                  <a:pt x="135775" y="135775"/>
+                </a:lnTo>
+                <a:close/>
+                <a:lnTo>
+                  <a:pt x="137160" y="137160"/>
                 </a:lnTo>
                 <a:close/>
               </a:path>
@@ -5070,8 +5070,8 @@
         </p:nvSpPr>
         <p:spPr>
           <a:xfrm>
-            <a:off x="5166360" y="1291590"/>
-            <a:ext cx="228600" cy="228600"/>
+            <a:off x="5120640" y="1428750"/>
+            <a:ext cx="137160" cy="137160"/>
           </a:xfrm>
           <a:custGeom>
             <a:avLst/>
@@ -5080,404 +5080,404 @@
             <a:cxnLst/>
             <a:rect l="l" t="t" r="r" b="b"/>
             <a:pathLst>
-              <a:path w="228600" h="228600">
+              <a:path w="137160" h="137160">
                 <a:moveTo>
-                  <a:pt x="0" y="228600"/>
+                  <a:pt x="0" y="137160"/>
                 </a:moveTo>
                 <a:lnTo>
-                  <a:pt x="2309" y="226291"/>
-                </a:lnTo>
-                <a:close/>
-                <a:lnTo>
-                  <a:pt x="4618" y="223982"/>
-                </a:lnTo>
-                <a:close/>
-                <a:lnTo>
-                  <a:pt x="6927" y="221673"/>
-                </a:lnTo>
-                <a:close/>
-                <a:lnTo>
-                  <a:pt x="9236" y="219364"/>
-                </a:lnTo>
-                <a:close/>
-                <a:lnTo>
-                  <a:pt x="11545" y="217055"/>
-                </a:lnTo>
-                <a:close/>
-                <a:lnTo>
-                  <a:pt x="13855" y="214745"/>
-                </a:lnTo>
-                <a:close/>
-                <a:lnTo>
-                  <a:pt x="16164" y="212436"/>
-                </a:lnTo>
-                <a:close/>
-                <a:lnTo>
-                  <a:pt x="18473" y="210127"/>
-                </a:lnTo>
-                <a:close/>
-                <a:lnTo>
-                  <a:pt x="20782" y="207818"/>
-                </a:lnTo>
-                <a:close/>
-                <a:lnTo>
-                  <a:pt x="23091" y="205509"/>
-                </a:lnTo>
-                <a:close/>
-                <a:lnTo>
-                  <a:pt x="25400" y="203200"/>
-                </a:lnTo>
-                <a:close/>
-                <a:lnTo>
-                  <a:pt x="27709" y="200891"/>
-                </a:lnTo>
-                <a:close/>
-                <a:lnTo>
-                  <a:pt x="30018" y="198582"/>
-                </a:lnTo>
-                <a:close/>
-                <a:lnTo>
-                  <a:pt x="32327" y="196273"/>
-                </a:lnTo>
-                <a:close/>
-                <a:lnTo>
-                  <a:pt x="34636" y="193964"/>
-                </a:lnTo>
-                <a:close/>
-                <a:lnTo>
-                  <a:pt x="36945" y="191655"/>
-                </a:lnTo>
-                <a:close/>
-                <a:lnTo>
-                  <a:pt x="39255" y="189345"/>
-                </a:lnTo>
-                <a:close/>
-                <a:lnTo>
-                  <a:pt x="41564" y="187036"/>
-                </a:lnTo>
-                <a:close/>
-                <a:lnTo>
-                  <a:pt x="43873" y="184727"/>
-                </a:lnTo>
-                <a:close/>
-                <a:lnTo>
-                  <a:pt x="46182" y="182418"/>
-                </a:lnTo>
-                <a:close/>
-                <a:lnTo>
-                  <a:pt x="48491" y="180109"/>
-                </a:lnTo>
-                <a:close/>
-                <a:lnTo>
-                  <a:pt x="50800" y="177800"/>
-                </a:lnTo>
-                <a:close/>
-                <a:lnTo>
-                  <a:pt x="53109" y="175491"/>
-                </a:lnTo>
-                <a:close/>
-                <a:lnTo>
-                  <a:pt x="55418" y="173182"/>
-                </a:lnTo>
-                <a:close/>
-                <a:lnTo>
-                  <a:pt x="57727" y="170873"/>
-                </a:lnTo>
-                <a:close/>
-                <a:lnTo>
-                  <a:pt x="60036" y="168564"/>
-                </a:lnTo>
-                <a:close/>
-                <a:lnTo>
-                  <a:pt x="62345" y="166255"/>
-                </a:lnTo>
-                <a:close/>
-                <a:lnTo>
-                  <a:pt x="64655" y="163945"/>
-                </a:lnTo>
-                <a:close/>
-                <a:lnTo>
-                  <a:pt x="66964" y="161636"/>
-                </a:lnTo>
-                <a:close/>
-                <a:lnTo>
-                  <a:pt x="69273" y="159327"/>
-                </a:lnTo>
-                <a:close/>
-                <a:lnTo>
-                  <a:pt x="71582" y="157018"/>
-                </a:lnTo>
-                <a:close/>
-                <a:lnTo>
-                  <a:pt x="73891" y="154709"/>
-                </a:lnTo>
-                <a:close/>
-                <a:lnTo>
-                  <a:pt x="76200" y="152400"/>
-                </a:lnTo>
-                <a:close/>
-                <a:lnTo>
-                  <a:pt x="78509" y="150091"/>
-                </a:lnTo>
-                <a:close/>
-                <a:lnTo>
-                  <a:pt x="80818" y="147782"/>
-                </a:lnTo>
-                <a:close/>
-                <a:lnTo>
-                  <a:pt x="83127" y="145473"/>
-                </a:lnTo>
-                <a:close/>
-                <a:lnTo>
-                  <a:pt x="85436" y="143164"/>
-                </a:lnTo>
-                <a:close/>
-                <a:lnTo>
-                  <a:pt x="87745" y="140855"/>
-                </a:lnTo>
-                <a:close/>
-                <a:lnTo>
-                  <a:pt x="90055" y="138545"/>
-                </a:lnTo>
-                <a:close/>
-                <a:lnTo>
-                  <a:pt x="92364" y="136236"/>
-                </a:lnTo>
-                <a:close/>
-                <a:lnTo>
-                  <a:pt x="94673" y="133927"/>
-                </a:lnTo>
-                <a:close/>
-                <a:lnTo>
-                  <a:pt x="96982" y="131618"/>
-                </a:lnTo>
-                <a:close/>
-                <a:lnTo>
-                  <a:pt x="99291" y="129309"/>
-                </a:lnTo>
-                <a:close/>
-                <a:lnTo>
-                  <a:pt x="101600" y="127000"/>
-                </a:lnTo>
-                <a:close/>
-                <a:lnTo>
-                  <a:pt x="103909" y="124691"/>
-                </a:lnTo>
-                <a:close/>
-                <a:lnTo>
-                  <a:pt x="106218" y="122382"/>
-                </a:lnTo>
-                <a:close/>
-                <a:lnTo>
-                  <a:pt x="108527" y="120073"/>
-                </a:lnTo>
-                <a:close/>
-                <a:lnTo>
-                  <a:pt x="110836" y="117764"/>
-                </a:lnTo>
-                <a:close/>
-                <a:lnTo>
-                  <a:pt x="113145" y="115455"/>
-                </a:lnTo>
-                <a:close/>
-                <a:lnTo>
-                  <a:pt x="115455" y="113145"/>
-                </a:lnTo>
-                <a:close/>
-                <a:lnTo>
-                  <a:pt x="117764" y="110836"/>
-                </a:lnTo>
-                <a:close/>
-                <a:lnTo>
-                  <a:pt x="120073" y="108527"/>
-                </a:lnTo>
-                <a:close/>
-                <a:lnTo>
-                  <a:pt x="122382" y="106218"/>
-                </a:lnTo>
-                <a:close/>
-                <a:lnTo>
-                  <a:pt x="124691" y="103909"/>
-                </a:lnTo>
-                <a:close/>
-                <a:lnTo>
-                  <a:pt x="127000" y="101600"/>
-                </a:lnTo>
-                <a:close/>
-                <a:lnTo>
-                  <a:pt x="129309" y="99291"/>
-                </a:lnTo>
-                <a:close/>
-                <a:lnTo>
-                  <a:pt x="131618" y="96982"/>
-                </a:lnTo>
-                <a:close/>
-                <a:lnTo>
-                  <a:pt x="133927" y="94673"/>
-                </a:lnTo>
-                <a:close/>
-                <a:lnTo>
-                  <a:pt x="136236" y="92364"/>
-                </a:lnTo>
-                <a:close/>
-                <a:lnTo>
-                  <a:pt x="138545" y="90055"/>
-                </a:lnTo>
-                <a:close/>
-                <a:lnTo>
-                  <a:pt x="140855" y="87745"/>
-                </a:lnTo>
-                <a:close/>
-                <a:lnTo>
-                  <a:pt x="143164" y="85436"/>
-                </a:lnTo>
-                <a:close/>
-                <a:lnTo>
-                  <a:pt x="145473" y="83127"/>
-                </a:lnTo>
-                <a:close/>
-                <a:lnTo>
-                  <a:pt x="147782" y="80818"/>
-                </a:lnTo>
-                <a:close/>
-                <a:lnTo>
-                  <a:pt x="150091" y="78509"/>
-                </a:lnTo>
-                <a:close/>
-                <a:lnTo>
-                  <a:pt x="152400" y="76200"/>
-                </a:lnTo>
-                <a:close/>
-                <a:lnTo>
-                  <a:pt x="154709" y="73891"/>
-                </a:lnTo>
-                <a:close/>
-                <a:lnTo>
-                  <a:pt x="157018" y="71582"/>
-                </a:lnTo>
-                <a:close/>
-                <a:lnTo>
-                  <a:pt x="159327" y="69273"/>
-                </a:lnTo>
-                <a:close/>
-                <a:lnTo>
-                  <a:pt x="161636" y="66964"/>
-                </a:lnTo>
-                <a:close/>
-                <a:lnTo>
-                  <a:pt x="163945" y="64655"/>
-                </a:lnTo>
-                <a:close/>
-                <a:lnTo>
-                  <a:pt x="166255" y="62345"/>
-                </a:lnTo>
-                <a:close/>
-                <a:lnTo>
-                  <a:pt x="168564" y="60036"/>
-                </a:lnTo>
-                <a:close/>
-                <a:lnTo>
-                  <a:pt x="170873" y="57727"/>
-                </a:lnTo>
-                <a:close/>
-                <a:lnTo>
-                  <a:pt x="173182" y="55418"/>
-                </a:lnTo>
-                <a:close/>
-                <a:lnTo>
-                  <a:pt x="175491" y="53109"/>
-                </a:lnTo>
-                <a:close/>
-                <a:lnTo>
-                  <a:pt x="177800" y="50800"/>
-                </a:lnTo>
-                <a:close/>
-                <a:lnTo>
-                  <a:pt x="180109" y="48491"/>
-                </a:lnTo>
-                <a:close/>
-                <a:lnTo>
-                  <a:pt x="182418" y="46182"/>
-                </a:lnTo>
-                <a:close/>
-                <a:lnTo>
-                  <a:pt x="184727" y="43873"/>
-                </a:lnTo>
-                <a:close/>
-                <a:lnTo>
-                  <a:pt x="187036" y="41564"/>
-                </a:lnTo>
-                <a:close/>
-                <a:lnTo>
-                  <a:pt x="189345" y="39255"/>
-                </a:lnTo>
-                <a:close/>
-                <a:lnTo>
-                  <a:pt x="191655" y="36945"/>
-                </a:lnTo>
-                <a:close/>
-                <a:lnTo>
-                  <a:pt x="193964" y="34636"/>
-                </a:lnTo>
-                <a:close/>
-                <a:lnTo>
-                  <a:pt x="196273" y="32327"/>
-                </a:lnTo>
-                <a:close/>
-                <a:lnTo>
-                  <a:pt x="198582" y="30018"/>
-                </a:lnTo>
-                <a:close/>
-                <a:lnTo>
-                  <a:pt x="200891" y="27709"/>
-                </a:lnTo>
-                <a:close/>
-                <a:lnTo>
-                  <a:pt x="203200" y="25400"/>
-                </a:lnTo>
-                <a:close/>
-                <a:lnTo>
-                  <a:pt x="205509" y="23091"/>
-                </a:lnTo>
-                <a:close/>
-                <a:lnTo>
-                  <a:pt x="207818" y="20782"/>
-                </a:lnTo>
-                <a:close/>
-                <a:lnTo>
-                  <a:pt x="210127" y="18473"/>
-                </a:lnTo>
-                <a:close/>
-                <a:lnTo>
-                  <a:pt x="212436" y="16164"/>
-                </a:lnTo>
-                <a:close/>
-                <a:lnTo>
-                  <a:pt x="214745" y="13855"/>
-                </a:lnTo>
-                <a:close/>
-                <a:lnTo>
-                  <a:pt x="217055" y="11545"/>
-                </a:lnTo>
-                <a:close/>
-                <a:lnTo>
-                  <a:pt x="219364" y="9236"/>
-                </a:lnTo>
-                <a:close/>
-                <a:lnTo>
-                  <a:pt x="221673" y="6927"/>
-                </a:lnTo>
-                <a:close/>
-                <a:lnTo>
-                  <a:pt x="223982" y="4618"/>
-                </a:lnTo>
-                <a:close/>
-                <a:lnTo>
-                  <a:pt x="226291" y="2309"/>
-                </a:lnTo>
-                <a:close/>
-                <a:lnTo>
-                  <a:pt x="228600" y="0"/>
+                  <a:pt x="1385" y="135775"/>
+                </a:lnTo>
+                <a:close/>
+                <a:lnTo>
+                  <a:pt x="2771" y="134389"/>
+                </a:lnTo>
+                <a:close/>
+                <a:lnTo>
+                  <a:pt x="4156" y="133004"/>
+                </a:lnTo>
+                <a:close/>
+                <a:lnTo>
+                  <a:pt x="5542" y="131618"/>
+                </a:lnTo>
+                <a:close/>
+                <a:lnTo>
+                  <a:pt x="6927" y="130233"/>
+                </a:lnTo>
+                <a:close/>
+                <a:lnTo>
+                  <a:pt x="8313" y="128847"/>
+                </a:lnTo>
+                <a:close/>
+                <a:lnTo>
+                  <a:pt x="9698" y="127462"/>
+                </a:lnTo>
+                <a:close/>
+                <a:lnTo>
+                  <a:pt x="11084" y="126076"/>
+                </a:lnTo>
+                <a:close/>
+                <a:lnTo>
+                  <a:pt x="12469" y="124691"/>
+                </a:lnTo>
+                <a:close/>
+                <a:lnTo>
+                  <a:pt x="13855" y="123305"/>
+                </a:lnTo>
+                <a:close/>
+                <a:lnTo>
+                  <a:pt x="15240" y="121920"/>
+                </a:lnTo>
+                <a:close/>
+                <a:lnTo>
+                  <a:pt x="16625" y="120535"/>
+                </a:lnTo>
+                <a:close/>
+                <a:lnTo>
+                  <a:pt x="18011" y="119149"/>
+                </a:lnTo>
+                <a:close/>
+                <a:lnTo>
+                  <a:pt x="19396" y="117764"/>
+                </a:lnTo>
+                <a:close/>
+                <a:lnTo>
+                  <a:pt x="20782" y="116378"/>
+                </a:lnTo>
+                <a:close/>
+                <a:lnTo>
+                  <a:pt x="22167" y="114993"/>
+                </a:lnTo>
+                <a:close/>
+                <a:lnTo>
+                  <a:pt x="23553" y="113607"/>
+                </a:lnTo>
+                <a:close/>
+                <a:lnTo>
+                  <a:pt x="24938" y="112222"/>
+                </a:lnTo>
+                <a:close/>
+                <a:lnTo>
+                  <a:pt x="26324" y="110836"/>
+                </a:lnTo>
+                <a:close/>
+                <a:lnTo>
+                  <a:pt x="27709" y="109451"/>
+                </a:lnTo>
+                <a:close/>
+                <a:lnTo>
+                  <a:pt x="29095" y="108065"/>
+                </a:lnTo>
+                <a:close/>
+                <a:lnTo>
+                  <a:pt x="30480" y="106680"/>
+                </a:lnTo>
+                <a:close/>
+                <a:lnTo>
+                  <a:pt x="31865" y="105295"/>
+                </a:lnTo>
+                <a:close/>
+                <a:lnTo>
+                  <a:pt x="33251" y="103909"/>
+                </a:lnTo>
+                <a:close/>
+                <a:lnTo>
+                  <a:pt x="34636" y="102524"/>
+                </a:lnTo>
+                <a:close/>
+                <a:lnTo>
+                  <a:pt x="36022" y="101138"/>
+                </a:lnTo>
+                <a:close/>
+                <a:lnTo>
+                  <a:pt x="37407" y="99753"/>
+                </a:lnTo>
+                <a:close/>
+                <a:lnTo>
+                  <a:pt x="38793" y="98367"/>
+                </a:lnTo>
+                <a:close/>
+                <a:lnTo>
+                  <a:pt x="40178" y="96982"/>
+                </a:lnTo>
+                <a:close/>
+                <a:lnTo>
+                  <a:pt x="41564" y="95596"/>
+                </a:lnTo>
+                <a:close/>
+                <a:lnTo>
+                  <a:pt x="42949" y="94211"/>
+                </a:lnTo>
+                <a:close/>
+                <a:lnTo>
+                  <a:pt x="44335" y="92825"/>
+                </a:lnTo>
+                <a:close/>
+                <a:lnTo>
+                  <a:pt x="45720" y="91440"/>
+                </a:lnTo>
+                <a:close/>
+                <a:lnTo>
+                  <a:pt x="47105" y="90055"/>
+                </a:lnTo>
+                <a:close/>
+                <a:lnTo>
+                  <a:pt x="48491" y="88669"/>
+                </a:lnTo>
+                <a:close/>
+                <a:lnTo>
+                  <a:pt x="49876" y="87284"/>
+                </a:lnTo>
+                <a:close/>
+                <a:lnTo>
+                  <a:pt x="51262" y="85898"/>
+                </a:lnTo>
+                <a:close/>
+                <a:lnTo>
+                  <a:pt x="52647" y="84513"/>
+                </a:lnTo>
+                <a:close/>
+                <a:lnTo>
+                  <a:pt x="54033" y="83127"/>
+                </a:lnTo>
+                <a:close/>
+                <a:lnTo>
+                  <a:pt x="55418" y="81742"/>
+                </a:lnTo>
+                <a:close/>
+                <a:lnTo>
+                  <a:pt x="56804" y="80356"/>
+                </a:lnTo>
+                <a:close/>
+                <a:lnTo>
+                  <a:pt x="58189" y="78971"/>
+                </a:lnTo>
+                <a:close/>
+                <a:lnTo>
+                  <a:pt x="59575" y="77585"/>
+                </a:lnTo>
+                <a:close/>
+                <a:lnTo>
+                  <a:pt x="60960" y="76200"/>
+                </a:lnTo>
+                <a:close/>
+                <a:lnTo>
+                  <a:pt x="62345" y="74815"/>
+                </a:lnTo>
+                <a:close/>
+                <a:lnTo>
+                  <a:pt x="63731" y="73429"/>
+                </a:lnTo>
+                <a:close/>
+                <a:lnTo>
+                  <a:pt x="65116" y="72044"/>
+                </a:lnTo>
+                <a:close/>
+                <a:lnTo>
+                  <a:pt x="66502" y="70658"/>
+                </a:lnTo>
+                <a:close/>
+                <a:lnTo>
+                  <a:pt x="67887" y="69273"/>
+                </a:lnTo>
+                <a:close/>
+                <a:lnTo>
+                  <a:pt x="69273" y="67887"/>
+                </a:lnTo>
+                <a:close/>
+                <a:lnTo>
+                  <a:pt x="70658" y="66502"/>
+                </a:lnTo>
+                <a:close/>
+                <a:lnTo>
+                  <a:pt x="72044" y="65116"/>
+                </a:lnTo>
+                <a:close/>
+                <a:lnTo>
+                  <a:pt x="73429" y="63731"/>
+                </a:lnTo>
+                <a:close/>
+                <a:lnTo>
+                  <a:pt x="74815" y="62345"/>
+                </a:lnTo>
+                <a:close/>
+                <a:lnTo>
+                  <a:pt x="76200" y="60960"/>
+                </a:lnTo>
+                <a:close/>
+                <a:lnTo>
+                  <a:pt x="77585" y="59575"/>
+                </a:lnTo>
+                <a:close/>
+                <a:lnTo>
+                  <a:pt x="78971" y="58189"/>
+                </a:lnTo>
+                <a:close/>
+                <a:lnTo>
+                  <a:pt x="80356" y="56804"/>
+                </a:lnTo>
+                <a:close/>
+                <a:lnTo>
+                  <a:pt x="81742" y="55418"/>
+                </a:lnTo>
+                <a:close/>
+                <a:lnTo>
+                  <a:pt x="83127" y="54033"/>
+                </a:lnTo>
+                <a:close/>
+                <a:lnTo>
+                  <a:pt x="84513" y="52647"/>
+                </a:lnTo>
+                <a:close/>
+                <a:lnTo>
+                  <a:pt x="85898" y="51262"/>
+                </a:lnTo>
+                <a:close/>
+                <a:lnTo>
+                  <a:pt x="87284" y="49876"/>
+                </a:lnTo>
+                <a:close/>
+                <a:lnTo>
+                  <a:pt x="88669" y="48491"/>
+                </a:lnTo>
+                <a:close/>
+                <a:lnTo>
+                  <a:pt x="90055" y="47105"/>
+                </a:lnTo>
+                <a:close/>
+                <a:lnTo>
+                  <a:pt x="91440" y="45720"/>
+                </a:lnTo>
+                <a:close/>
+                <a:lnTo>
+                  <a:pt x="92825" y="44335"/>
+                </a:lnTo>
+                <a:close/>
+                <a:lnTo>
+                  <a:pt x="94211" y="42949"/>
+                </a:lnTo>
+                <a:close/>
+                <a:lnTo>
+                  <a:pt x="95596" y="41564"/>
+                </a:lnTo>
+                <a:close/>
+                <a:lnTo>
+                  <a:pt x="96982" y="40178"/>
+                </a:lnTo>
+                <a:close/>
+                <a:lnTo>
+                  <a:pt x="98367" y="38793"/>
+                </a:lnTo>
+                <a:close/>
+                <a:lnTo>
+                  <a:pt x="99753" y="37407"/>
+                </a:lnTo>
+                <a:close/>
+                <a:lnTo>
+                  <a:pt x="101138" y="36022"/>
+                </a:lnTo>
+                <a:close/>
+                <a:lnTo>
+                  <a:pt x="102524" y="34636"/>
+                </a:lnTo>
+                <a:close/>
+                <a:lnTo>
+                  <a:pt x="103909" y="33251"/>
+                </a:lnTo>
+                <a:close/>
+                <a:lnTo>
+                  <a:pt x="105295" y="31865"/>
+                </a:lnTo>
+                <a:close/>
+                <a:lnTo>
+                  <a:pt x="106680" y="30480"/>
+                </a:lnTo>
+                <a:close/>
+                <a:lnTo>
+                  <a:pt x="108065" y="29095"/>
+                </a:lnTo>
+                <a:close/>
+                <a:lnTo>
+                  <a:pt x="109451" y="27709"/>
+                </a:lnTo>
+                <a:close/>
+                <a:lnTo>
+                  <a:pt x="110836" y="26324"/>
+                </a:lnTo>
+                <a:close/>
+                <a:lnTo>
+                  <a:pt x="112222" y="24938"/>
+                </a:lnTo>
+                <a:close/>
+                <a:lnTo>
+                  <a:pt x="113607" y="23553"/>
+                </a:lnTo>
+                <a:close/>
+                <a:lnTo>
+                  <a:pt x="114993" y="22167"/>
+                </a:lnTo>
+                <a:close/>
+                <a:lnTo>
+                  <a:pt x="116378" y="20782"/>
+                </a:lnTo>
+                <a:close/>
+                <a:lnTo>
+                  <a:pt x="117764" y="19396"/>
+                </a:lnTo>
+                <a:close/>
+                <a:lnTo>
+                  <a:pt x="119149" y="18011"/>
+                </a:lnTo>
+                <a:close/>
+                <a:lnTo>
+                  <a:pt x="120535" y="16625"/>
+                </a:lnTo>
+                <a:close/>
+                <a:lnTo>
+                  <a:pt x="121920" y="15240"/>
+                </a:lnTo>
+                <a:close/>
+                <a:lnTo>
+                  <a:pt x="123305" y="13855"/>
+                </a:lnTo>
+                <a:close/>
+                <a:lnTo>
+                  <a:pt x="124691" y="12469"/>
+                </a:lnTo>
+                <a:close/>
+                <a:lnTo>
+                  <a:pt x="126076" y="11084"/>
+                </a:lnTo>
+                <a:close/>
+                <a:lnTo>
+                  <a:pt x="127462" y="9698"/>
+                </a:lnTo>
+                <a:close/>
+                <a:lnTo>
+                  <a:pt x="128847" y="8313"/>
+                </a:lnTo>
+                <a:close/>
+                <a:lnTo>
+                  <a:pt x="130233" y="6927"/>
+                </a:lnTo>
+                <a:close/>
+                <a:lnTo>
+                  <a:pt x="131618" y="5542"/>
+                </a:lnTo>
+                <a:close/>
+                <a:lnTo>
+                  <a:pt x="133004" y="4156"/>
+                </a:lnTo>
+                <a:close/>
+                <a:lnTo>
+                  <a:pt x="134389" y="2771"/>
+                </a:lnTo>
+                <a:close/>
+                <a:lnTo>
+                  <a:pt x="135775" y="1385"/>
+                </a:lnTo>
+                <a:close/>
+                <a:lnTo>
+                  <a:pt x="137160" y="0"/>
                 </a:lnTo>
                 <a:close/>
               </a:path>
@@ -5519,7 +5519,7 @@
         </p:nvSpPr>
         <p:spPr>
           <a:xfrm>
-            <a:off x="4775200" y="2345690"/>
+            <a:off x="4318000" y="2299970"/>
             <a:ext cx="1524000" cy="508000"/>
           </a:xfrm>
           <a:prstGeom prst="rect">
@@ -5542,6 +5542,114 @@
               </a:defRPr>
             </a:pPr>
             <a:r>
+              <a:t>O</a:t>
+            </a:r>
+          </a:p>
+        </p:txBody>
+      </p:sp>
+      <p:sp>
+        <p:nvSpPr>
+          <p:cNvPr id="13" name="TextBox 12"/>
+          <p:cNvSpPr txBox="1"/>
+          <p:nvPr/>
+        </p:nvSpPr>
+        <p:spPr>
+          <a:xfrm>
+            <a:off x="5506720" y="2299970"/>
+            <a:ext cx="1524000" cy="508000"/>
+          </a:xfrm>
+          <a:prstGeom prst="rect">
+            <a:avLst/>
+          </a:prstGeom>
+          <a:noFill/>
+        </p:spPr>
+        <p:txBody>
+          <a:bodyPr wrap="none">
+            <a:spAutoFit/>
+          </a:bodyPr>
+          <a:lstStyle/>
+          <a:p>
+            <a:pPr>
+              <a:defRPr sz="1400" b="1">
+                <a:solidFill>
+                  <a:srgbClr val="FFFFFF"/>
+                </a:solidFill>
+                <a:latin typeface="Inter"/>
+              </a:defRPr>
+            </a:pPr>
+            <a:r>
+              <a:t>x</a:t>
+            </a:r>
+          </a:p>
+        </p:txBody>
+      </p:sp>
+      <p:sp>
+        <p:nvSpPr>
+          <p:cNvPr id="14" name="TextBox 13"/>
+          <p:cNvSpPr txBox="1"/>
+          <p:nvPr/>
+        </p:nvSpPr>
+        <p:spPr>
+          <a:xfrm>
+            <a:off x="4272280" y="608330"/>
+            <a:ext cx="1524000" cy="508000"/>
+          </a:xfrm>
+          <a:prstGeom prst="rect">
+            <a:avLst/>
+          </a:prstGeom>
+          <a:noFill/>
+        </p:spPr>
+        <p:txBody>
+          <a:bodyPr wrap="none">
+            <a:spAutoFit/>
+          </a:bodyPr>
+          <a:lstStyle/>
+          <a:p>
+            <a:pPr>
+              <a:defRPr sz="1400" b="1">
+                <a:solidFill>
+                  <a:srgbClr val="FFFFFF"/>
+                </a:solidFill>
+                <a:latin typeface="Inter"/>
+              </a:defRPr>
+            </a:pPr>
+            <a:r>
+              <a:t>y</a:t>
+            </a:r>
+          </a:p>
+        </p:txBody>
+      </p:sp>
+      <p:sp>
+        <p:nvSpPr>
+          <p:cNvPr id="15" name="TextBox 14"/>
+          <p:cNvSpPr txBox="1"/>
+          <p:nvPr/>
+        </p:nvSpPr>
+        <p:spPr>
+          <a:xfrm>
+            <a:off x="4775200" y="2322830"/>
+            <a:ext cx="1524000" cy="508000"/>
+          </a:xfrm>
+          <a:prstGeom prst="rect">
+            <a:avLst/>
+          </a:prstGeom>
+          <a:noFill/>
+        </p:spPr>
+        <p:txBody>
+          <a:bodyPr wrap="none">
+            <a:spAutoFit/>
+          </a:bodyPr>
+          <a:lstStyle/>
+          <a:p>
+            <a:pPr>
+              <a:defRPr sz="1400" b="1">
+                <a:solidFill>
+                  <a:srgbClr val="FFFFFF"/>
+                </a:solidFill>
+                <a:latin typeface="Inter"/>
+              </a:defRPr>
+            </a:pPr>
+            <a:r>
               <a:t>1</a:t>
             </a:r>
           </a:p>
@@ -5549,7 +5657,7 @@
       </p:sp>
       <p:sp>
         <p:nvSpPr>
-          <p:cNvPr id="13" name="TextBox 12"/>
+          <p:cNvPr id="16" name="TextBox 15"/>
           <p:cNvSpPr txBox="1"/>
           <p:nvPr/>
         </p:nvSpPr>
@@ -5585,7 +5693,7 @@
       </p:sp>
       <p:sp>
         <p:nvSpPr>
-          <p:cNvPr id="14" name="TextBox 13"/>
+          <p:cNvPr id="17" name="TextBox 16"/>
           <p:cNvSpPr txBox="1"/>
           <p:nvPr/>
         </p:nvSpPr>

</xml_diff>